<commit_message>
Update slides deck PPTX and HTML to strictly mirror official 4 competition sections with visual AWS architecture diagram
</commit_message>
<xml_diff>
--- a/新北市校園治理情報平台_提案簡報.pptx
+++ b/新北市校園治理情報平台_提案簡報.pptx
@@ -3339,7 +3339,7 @@
         <p:spPr>
           <a:xfrm>
             <a:off x="731520" y="365760"/>
-            <a:ext cx="10698480" cy="365760"/>
+            <a:ext cx="10698480" cy="320040"/>
           </a:xfrm>
           <a:prstGeom prst="rect">
             <a:avLst/>
@@ -3360,7 +3360,7 @@
               </a:defRPr>
             </a:pPr>
             <a:r>
-              <a:t>AWS 黑客松競賽提案 ｜ 教育局命題：教保機構風險監測</a:t>
+              <a:t>AWS 黑客松競賽提案 ｜ 總結 ｜ 成果交付</a:t>
             </a:r>
           </a:p>
         </p:txBody>
@@ -3374,7 +3374,7 @@
         <p:spPr>
           <a:xfrm>
             <a:off x="731520" y="640080"/>
-            <a:ext cx="10698480" cy="640080"/>
+            <a:ext cx="10698480" cy="594360"/>
           </a:xfrm>
           <a:prstGeom prst="rect">
             <a:avLst/>
@@ -3388,14 +3388,14 @@
           <a:lstStyle/>
           <a:p>
             <a:pPr>
-              <a:defRPr sz="2400" b="1">
+              <a:defRPr sz="2300" b="1">
                 <a:solidFill>
                   <a:srgbClr val="0F172A"/>
                 </a:solidFill>
               </a:defRPr>
             </a:pPr>
             <a:r>
-              <a:t>九、總結與競賽成果交付清單 (Deliverables)</a:t>
+              <a:t>總結與競賽成果交付清單 (Deliverables &amp; Summary)</a:t>
             </a:r>
           </a:p>
         </p:txBody>
@@ -3453,8 +3453,8 @@
         </p:nvSpPr>
         <p:spPr>
           <a:xfrm>
-            <a:off x="1463040" y="1920240"/>
-            <a:ext cx="9235440" cy="3840480"/>
+            <a:off x="1463040" y="1874519"/>
+            <a:ext cx="9235440" cy="3931920"/>
           </a:xfrm>
           <a:prstGeom prst="rect">
             <a:avLst/>
@@ -3468,7 +3468,7 @@
           <a:lstStyle/>
           <a:p>
             <a:pPr>
-              <a:defRPr sz="2000" b="1">
+              <a:defRPr sz="1900" b="1">
                 <a:solidFill>
                   <a:srgbClr val="2563EB"/>
                 </a:solidFill>
@@ -3481,9 +3481,9 @@
           <a:p>
             <a:pPr>
               <a:spcBef>
-                <a:spcPts val="800"/>
+                <a:spcPts val="600"/>
               </a:spcBef>
-              <a:defRPr sz="1300">
+              <a:defRPr sz="1200">
                 <a:solidFill>
                   <a:srgbClr val="0F172A"/>
                 </a:solidFill>
@@ -3496,9 +3496,9 @@
           <a:p>
             <a:pPr>
               <a:spcBef>
-                <a:spcPts val="800"/>
+                <a:spcPts val="600"/>
               </a:spcBef>
-              <a:defRPr sz="1300">
+              <a:defRPr sz="1200">
                 <a:solidFill>
                   <a:srgbClr val="0F172A"/>
                 </a:solidFill>
@@ -3511,24 +3511,24 @@
           <a:p>
             <a:pPr>
               <a:spcBef>
-                <a:spcPts val="800"/>
+                <a:spcPts val="600"/>
               </a:spcBef>
-              <a:defRPr sz="1300">
+              <a:defRPr sz="1200">
                 <a:solidFill>
                   <a:srgbClr val="0F172A"/>
                 </a:solidFill>
               </a:defRPr>
             </a:pPr>
             <a:r>
-              <a:t>• 【3. AWS 雲端技術架構】：符合 S3 Block Public Access、VPC Private Subnet、Bedrock RPS&lt;=1 之高規格安全架構</a:t>
+              <a:t>• 【3. AWS 雲端技術架構】：嚴格符合 S3 Block Public Access、VPC Private Subnet、Bedrock RPS&lt;=1 之高規格安全架構</a:t>
             </a:r>
           </a:p>
           <a:p>
             <a:pPr>
               <a:spcBef>
-                <a:spcPts val="800"/>
+                <a:spcPts val="600"/>
               </a:spcBef>
-              <a:defRPr sz="1300">
+              <a:defRPr sz="1200">
                 <a:solidFill>
                   <a:srgbClr val="0F172A"/>
                 </a:solidFill>
@@ -3541,24 +3541,24 @@
           <a:p>
             <a:pPr>
               <a:spcBef>
-                <a:spcPts val="800"/>
+                <a:spcPts val="600"/>
               </a:spcBef>
-              <a:defRPr sz="1300">
+              <a:defRPr sz="1200">
                 <a:solidFill>
                   <a:srgbClr val="0F172A"/>
                 </a:solidFill>
               </a:defRPr>
             </a:pPr>
             <a:r>
-              <a:t>• 【5. Live Demo 錄製影片】：展示新北 29 區地圖、高風險過濾、雙校雷達與 AI 稽查室 (2.5 分鐘影片連結)</a:t>
+              <a:t>• 【5. 提案簡報檔案】：包含 新北市校園治理情報平台_提案簡報.pptx 與線上高解析度 HTML/PDF 投影片</a:t>
             </a:r>
           </a:p>
           <a:p>
             <a:pPr>
               <a:spcBef>
-                <a:spcPts val="800"/>
+                <a:spcPts val="600"/>
               </a:spcBef>
-              <a:defRPr sz="1300">
+              <a:defRPr sz="1200">
                 <a:solidFill>
                   <a:srgbClr val="0F172A"/>
                 </a:solidFill>
@@ -3571,7 +3571,7 @@
           <a:p>
             <a:pPr algn="ctr">
               <a:spcBef>
-                <a:spcPts val="1800"/>
+                <a:spcPts val="1600"/>
               </a:spcBef>
               <a:defRPr sz="1800" b="1">
                 <a:solidFill>
@@ -3655,7 +3655,7 @@
         <p:spPr>
           <a:xfrm>
             <a:off x="731520" y="365760"/>
-            <a:ext cx="10698480" cy="365760"/>
+            <a:ext cx="10698480" cy="320040"/>
           </a:xfrm>
           <a:prstGeom prst="rect">
             <a:avLst/>
@@ -3676,7 +3676,7 @@
               </a:defRPr>
             </a:pPr>
             <a:r>
-              <a:t>AWS 黑客松競賽提案 ｜ 教育局命題：教保機構風險監測</a:t>
+              <a:t>AWS 黑客松競賽提案 ｜ AGENDA 簡報大綱</a:t>
             </a:r>
           </a:p>
         </p:txBody>
@@ -3690,7 +3690,7 @@
         <p:spPr>
           <a:xfrm>
             <a:off x="731520" y="640080"/>
-            <a:ext cx="10698480" cy="640080"/>
+            <a:ext cx="10698480" cy="594360"/>
           </a:xfrm>
           <a:prstGeom prst="rect">
             <a:avLst/>
@@ -3704,14 +3704,14 @@
           <a:lstStyle/>
           <a:p>
             <a:pPr>
-              <a:defRPr sz="2400" b="1">
+              <a:defRPr sz="2300" b="1">
                 <a:solidFill>
                   <a:srgbClr val="0F172A"/>
                 </a:solidFill>
               </a:defRPr>
             </a:pPr>
             <a:r>
-              <a:t>一、問題痛點與命題目標 (Pain Points &amp; Objective)</a:t>
+              <a:t>提案大綱：對齊大會指定 4 大核心項目</a:t>
             </a:r>
           </a:p>
         </p:txBody>
@@ -3725,7 +3725,7 @@
         <p:spPr>
           <a:xfrm>
             <a:off x="731520" y="1645920"/>
-            <a:ext cx="3328416" cy="4389120"/>
+            <a:ext cx="2468880" cy="4389120"/>
           </a:xfrm>
           <a:prstGeom prst="roundRect">
             <a:avLst/>
@@ -3735,7 +3735,7 @@
           </a:solidFill>
           <a:ln w="15240">
             <a:solidFill>
-              <a:srgbClr val="E2E8F0"/>
+              <a:srgbClr val="2563EB"/>
             </a:solidFill>
           </a:ln>
         </p:spPr>
@@ -3769,8 +3769,8 @@
         </p:nvSpPr>
         <p:spPr>
           <a:xfrm>
-            <a:off x="960120" y="1874519"/>
-            <a:ext cx="2871216" cy="3931920"/>
+            <a:off x="868680" y="1828800"/>
+            <a:ext cx="2194560" cy="3931920"/>
           </a:xfrm>
           <a:prstGeom prst="rect">
             <a:avLst/>
@@ -3784,44 +3784,71 @@
           <a:lstStyle/>
           <a:p>
             <a:pPr>
-              <a:defRPr sz="1700" b="1">
-                <a:solidFill>
-                  <a:srgbClr val="DC2626"/>
-                </a:solidFill>
-              </a:defRPr>
-            </a:pPr>
-            <a:r>
-              <a:t>🚨 痛點一：事後被動申訴，為時已晚</a:t>
+              <a:defRPr sz="2800" b="1">
+                <a:solidFill>
+                  <a:srgbClr val="2563EB"/>
+                </a:solidFill>
+              </a:defRPr>
+            </a:pPr>
+            <a:r>
+              <a:t>01</a:t>
             </a:r>
           </a:p>
           <a:p>
             <a:pPr>
               <a:spcBef>
-                <a:spcPts val="800"/>
+                <a:spcPts val="400"/>
               </a:spcBef>
-              <a:defRPr sz="1200" b="1">
+              <a:defRPr sz="1600" b="1">
                 <a:solidFill>
                   <a:srgbClr val="0F172A"/>
                 </a:solidFill>
               </a:defRPr>
             </a:pPr>
             <a:r>
-              <a:t>重大案件爆發前無預兆</a:t>
+              <a:t>解決方案說明</a:t>
             </a:r>
           </a:p>
           <a:p>
             <a:pPr>
               <a:spcBef>
-                <a:spcPts val="1400"/>
+                <a:spcPts val="400"/>
               </a:spcBef>
-              <a:defRPr sz="1300">
+              <a:defRPr sz="1100" b="1">
+                <a:solidFill>
+                  <a:srgbClr val="2563EB"/>
+                </a:solidFill>
+              </a:defRPr>
+            </a:pPr>
+            <a:r>
+              <a:t>5D 模型與三級風險梯隊</a:t>
+            </a:r>
+          </a:p>
+          <a:p>
+            <a:pPr>
+              <a:spcBef>
+                <a:spcPts val="1200"/>
+              </a:spcBef>
+              <a:defRPr sz="1200">
                 <a:solidFill>
                   <a:srgbClr val="64748B"/>
                 </a:solidFill>
               </a:defRPr>
             </a:pPr>
             <a:r>
-              <a:t>傳統管理仰賴民眾被動檢舉，當超收幼兒（如 1:15 違規超收）、黑牌教保員或不當管教被發現時，孩子身心往往已受傷害，教育局被動滅火。</a:t>
+              <a:t>• 現行稽查三大痛點剖析</a:t>
+            </a:r>
+            <a:br/>
+            <a:r>
+              <a:t>• 獨創 5D 校園多維治理指標</a:t>
+            </a:r>
+            <a:br/>
+            <a:r>
+              <a:t>• 新北 468 所機構實測分級</a:t>
+            </a:r>
+            <a:br/>
+            <a:r>
+              <a:t>• 事前預警機制與稽查賦能</a:t>
             </a:r>
           </a:p>
         </p:txBody>
@@ -3834,8 +3861,8 @@
         </p:nvSpPr>
         <p:spPr>
           <a:xfrm>
-            <a:off x="4407408" y="1645920"/>
-            <a:ext cx="3328416" cy="4389120"/>
+            <a:off x="3483864" y="1645920"/>
+            <a:ext cx="2468880" cy="4389120"/>
           </a:xfrm>
           <a:prstGeom prst="roundRect">
             <a:avLst/>
@@ -3845,7 +3872,7 @@
           </a:solidFill>
           <a:ln w="15240">
             <a:solidFill>
-              <a:srgbClr val="E2E8F0"/>
+              <a:srgbClr val="10B981"/>
             </a:solidFill>
           </a:ln>
         </p:spPr>
@@ -3879,8 +3906,8 @@
         </p:nvSpPr>
         <p:spPr>
           <a:xfrm>
-            <a:off x="4636008" y="1874519"/>
-            <a:ext cx="2871216" cy="3931920"/>
+            <a:off x="3621024" y="1828800"/>
+            <a:ext cx="2194560" cy="3931920"/>
           </a:xfrm>
           <a:prstGeom prst="rect">
             <a:avLst/>
@@ -3894,44 +3921,71 @@
           <a:lstStyle/>
           <a:p>
             <a:pPr>
-              <a:defRPr sz="1700" b="1">
-                <a:solidFill>
-                  <a:srgbClr val="2563EB"/>
-                </a:solidFill>
-              </a:defRPr>
-            </a:pPr>
-            <a:r>
-              <a:t>📂 痛點二：局處資料孤島，查核斷鏈</a:t>
+              <a:defRPr sz="2800" b="1">
+                <a:solidFill>
+                  <a:srgbClr val="10B981"/>
+                </a:solidFill>
+              </a:defRPr>
+            </a:pPr>
+            <a:r>
+              <a:t>02</a:t>
             </a:r>
           </a:p>
           <a:p>
             <a:pPr>
               <a:spcBef>
-                <a:spcPts val="800"/>
+                <a:spcPts val="400"/>
               </a:spcBef>
-              <a:defRPr sz="1200" b="1">
+              <a:defRPr sz="1600" b="1">
                 <a:solidFill>
                   <a:srgbClr val="0F172A"/>
                 </a:solidFill>
               </a:defRPr>
             </a:pPr>
             <a:r>
-              <a:t>資訊散落各系統難整合</a:t>
+              <a:t>數據及資料運用</a:t>
             </a:r>
           </a:p>
           <a:p>
             <a:pPr>
               <a:spcBef>
-                <a:spcPts val="1400"/>
+                <a:spcPts val="400"/>
               </a:spcBef>
-              <a:defRPr sz="1300">
+              <a:defRPr sz="1100" b="1">
+                <a:solidFill>
+                  <a:srgbClr val="10B981"/>
+                </a:solidFill>
+              </a:defRPr>
+            </a:pPr>
+            <a:r>
+              <a:t>4 大官方數據源與防弊模型</a:t>
+            </a:r>
+          </a:p>
+          <a:p>
+            <a:pPr>
+              <a:spcBef>
+                <a:spcPts val="1200"/>
+              </a:spcBef>
+              <a:defRPr sz="1200">
                 <a:solidFill>
                   <a:srgbClr val="64748B"/>
                 </a:solidFill>
               </a:defRPr>
             </a:pPr>
             <a:r>
-              <a:t>裁罰紀錄、食安中央廚房食材登錄、政府採購合約、消防公安與家長網路評價散落各處，缺乏統一畫像，無法跨維度綜合研判風險。</a:t>
+              <a:t>• 教育部、新北OpenData、採購網</a:t>
+            </a:r>
+            <a:br/>
+            <a:r>
+              <a:t>• 班佛定律 (Benford's Law) 假帳檢定</a:t>
+            </a:r>
+            <a:br/>
+            <a:r>
+              <a:t>• Google 評論 NLP 情感探勘</a:t>
+            </a:r>
+            <a:br/>
+            <a:r>
+              <a:t>• 多因子動態風險量化演算法</a:t>
             </a:r>
           </a:p>
         </p:txBody>
@@ -3944,8 +3998,8 @@
         </p:nvSpPr>
         <p:spPr>
           <a:xfrm>
-            <a:off x="8083296" y="1645920"/>
-            <a:ext cx="3328416" cy="4389120"/>
+            <a:off x="6236208" y="1645920"/>
+            <a:ext cx="2468880" cy="4389120"/>
           </a:xfrm>
           <a:prstGeom prst="roundRect">
             <a:avLst/>
@@ -3955,7 +4009,7 @@
           </a:solidFill>
           <a:ln w="15240">
             <a:solidFill>
-              <a:srgbClr val="E2E8F0"/>
+              <a:srgbClr val="D97706"/>
             </a:solidFill>
           </a:ln>
         </p:spPr>
@@ -3989,8 +4043,8 @@
         </p:nvSpPr>
         <p:spPr>
           <a:xfrm>
-            <a:off x="8311896" y="1874519"/>
-            <a:ext cx="2871216" cy="3931920"/>
+            <a:off x="6373368" y="1828800"/>
+            <a:ext cx="2194560" cy="3931920"/>
           </a:xfrm>
           <a:prstGeom prst="rect">
             <a:avLst/>
@@ -4004,44 +4058,208 @@
           <a:lstStyle/>
           <a:p>
             <a:pPr>
-              <a:defRPr sz="1700" b="1">
-                <a:solidFill>
-                  <a:srgbClr val="2563EB"/>
-                </a:solidFill>
-              </a:defRPr>
-            </a:pPr>
-            <a:r>
-              <a:t>⏳ 痛點三：稽查人力有限，難以普查</a:t>
+              <a:defRPr sz="2800" b="1">
+                <a:solidFill>
+                  <a:srgbClr val="D97706"/>
+                </a:solidFill>
+              </a:defRPr>
+            </a:pPr>
+            <a:r>
+              <a:t>03</a:t>
             </a:r>
           </a:p>
           <a:p>
             <a:pPr>
               <a:spcBef>
-                <a:spcPts val="800"/>
+                <a:spcPts val="400"/>
               </a:spcBef>
-              <a:defRPr sz="1200" b="1">
+              <a:defRPr sz="1600" b="1">
                 <a:solidFill>
                   <a:srgbClr val="0F172A"/>
                 </a:solidFill>
               </a:defRPr>
             </a:pPr>
             <a:r>
-              <a:t>新北逾 1,500 所機構龐大負擔</a:t>
+              <a:t>AWS 雲端技術架構</a:t>
             </a:r>
           </a:p>
           <a:p>
             <a:pPr>
               <a:spcBef>
-                <a:spcPts val="1400"/>
+                <a:spcPts val="400"/>
               </a:spcBef>
-              <a:defRPr sz="1300">
+              <a:defRPr sz="1100" b="1">
+                <a:solidFill>
+                  <a:srgbClr val="D97706"/>
+                </a:solidFill>
+              </a:defRPr>
+            </a:pPr>
+            <a:r>
+              <a:t>含架構圖與大會安全檢核</a:t>
+            </a:r>
+          </a:p>
+          <a:p>
+            <a:pPr>
+              <a:spcBef>
+                <a:spcPts val="1200"/>
+              </a:spcBef>
+              <a:defRPr sz="1200">
                 <a:solidFill>
                   <a:srgbClr val="64748B"/>
                 </a:solidFill>
               </a:defRPr>
             </a:pPr>
             <a:r>
-              <a:t>新北市公私立各級學校與幼托多達 1,500 餘所，專任稽查員難以進行高頻率地毯式普查，急需「AI 智慧分級標註」，將有限人力精準投放在高風險機構。</a:t>
+              <a:t>• 全端無伺服器與微服務拓撲圖</a:t>
+            </a:r>
+            <a:br/>
+            <a:r>
+              <a:t>• S3 Block Public Access + OAC</a:t>
+            </a:r>
+            <a:br/>
+            <a:r>
+              <a:t>• VPC 私有子網 Aurora RDS</a:t>
+            </a:r>
+            <a:br/>
+            <a:r>
+              <a:t>• Bedrock RPS &lt;= 1 令牌桶限流</a:t>
+            </a:r>
+          </a:p>
+        </p:txBody>
+      </p:sp>
+      <p:sp>
+        <p:nvSpPr>
+          <p:cNvPr id="11" name="Rounded Rectangle 10"/>
+          <p:cNvSpPr/>
+          <p:nvPr/>
+        </p:nvSpPr>
+        <p:spPr>
+          <a:xfrm>
+            <a:off x="8988552" y="1645920"/>
+            <a:ext cx="2468880" cy="4389120"/>
+          </a:xfrm>
+          <a:prstGeom prst="roundRect">
+            <a:avLst/>
+          </a:prstGeom>
+          <a:solidFill>
+            <a:srgbClr val="FFFFFF"/>
+          </a:solidFill>
+          <a:ln w="15240">
+            <a:solidFill>
+              <a:srgbClr val="8B5CF6"/>
+            </a:solidFill>
+          </a:ln>
+        </p:spPr>
+        <p:style>
+          <a:lnRef idx="1">
+            <a:schemeClr val="accent1"/>
+          </a:lnRef>
+          <a:fillRef idx="3">
+            <a:schemeClr val="accent1"/>
+          </a:fillRef>
+          <a:effectRef idx="2">
+            <a:schemeClr val="accent1"/>
+          </a:effectRef>
+          <a:fontRef idx="minor">
+            <a:schemeClr val="lt1"/>
+          </a:fontRef>
+        </p:style>
+        <p:txBody>
+          <a:bodyPr rtlCol="0" anchor="ctr"/>
+          <a:lstStyle/>
+          <a:p>
+            <a:pPr algn="ctr"/>
+          </a:p>
+        </p:txBody>
+      </p:sp>
+      <p:sp>
+        <p:nvSpPr>
+          <p:cNvPr id="12" name="TextBox 11"/>
+          <p:cNvSpPr txBox="1"/>
+          <p:nvPr/>
+        </p:nvSpPr>
+        <p:spPr>
+          <a:xfrm>
+            <a:off x="9125712" y="1828800"/>
+            <a:ext cx="2194560" cy="3931920"/>
+          </a:xfrm>
+          <a:prstGeom prst="rect">
+            <a:avLst/>
+          </a:prstGeom>
+          <a:noFill/>
+        </p:spPr>
+        <p:txBody>
+          <a:bodyPr wrap="square">
+            <a:spAutoFit/>
+          </a:bodyPr>
+          <a:lstStyle/>
+          <a:p>
+            <a:pPr>
+              <a:defRPr sz="2800" b="1">
+                <a:solidFill>
+                  <a:srgbClr val="8B5CF6"/>
+                </a:solidFill>
+              </a:defRPr>
+            </a:pPr>
+            <a:r>
+              <a:t>04</a:t>
+            </a:r>
+          </a:p>
+          <a:p>
+            <a:pPr>
+              <a:spcBef>
+                <a:spcPts val="400"/>
+              </a:spcBef>
+              <a:defRPr sz="1600" b="1">
+                <a:solidFill>
+                  <a:srgbClr val="0F172A"/>
+                </a:solidFill>
+              </a:defRPr>
+            </a:pPr>
+            <a:r>
+              <a:t>使用介面及操作流程</a:t>
+            </a:r>
+          </a:p>
+          <a:p>
+            <a:pPr>
+              <a:spcBef>
+                <a:spcPts val="400"/>
+              </a:spcBef>
+              <a:defRPr sz="1100" b="1">
+                <a:solidFill>
+                  <a:srgbClr val="8B5CF6"/>
+                </a:solidFill>
+              </a:defRPr>
+            </a:pPr>
+            <a:r>
+              <a:t>GIS、雷達對比與 AI 稽查</a:t>
+            </a:r>
+          </a:p>
+          <a:p>
+            <a:pPr>
+              <a:spcBef>
+                <a:spcPts val="1200"/>
+              </a:spcBef>
+              <a:defRPr sz="1200">
+                <a:solidFill>
+                  <a:srgbClr val="64748B"/>
+                </a:solidFill>
+              </a:defRPr>
+            </a:pPr>
+            <a:r>
+              <a:t>• 新北 29 區 GIS 地理熱點圖台</a:t>
+            </a:r>
+            <a:br/>
+            <a:r>
+              <a:t>• 機構名冊與 5D 深度稽查抽屜</a:t>
+            </a:r>
+            <a:br/>
+            <a:r>
+              <a:t>• 雙校五維雷達對比分析</a:t>
+            </a:r>
+            <a:br/>
+            <a:r>
+              <a:t>• 教育局 4 步現場稽查 SOP</a:t>
             </a:r>
           </a:p>
         </p:txBody>
@@ -4116,7 +4334,7 @@
         <p:spPr>
           <a:xfrm>
             <a:off x="731520" y="365760"/>
-            <a:ext cx="10698480" cy="365760"/>
+            <a:ext cx="10698480" cy="320040"/>
           </a:xfrm>
           <a:prstGeom prst="rect">
             <a:avLst/>
@@ -4137,7 +4355,7 @@
               </a:defRPr>
             </a:pPr>
             <a:r>
-              <a:t>AWS 黑客松競賽提案 ｜ 教育局命題：教保機構風險監測</a:t>
+              <a:t>AWS 黑客松競賽提案 ｜ 項目一 ｜ 解決方案說明</a:t>
             </a:r>
           </a:p>
         </p:txBody>
@@ -4151,7 +4369,7 @@
         <p:spPr>
           <a:xfrm>
             <a:off x="731520" y="640080"/>
-            <a:ext cx="10698480" cy="640080"/>
+            <a:ext cx="10698480" cy="594360"/>
           </a:xfrm>
           <a:prstGeom prst="rect">
             <a:avLst/>
@@ -4165,14 +4383,14 @@
           <a:lstStyle/>
           <a:p>
             <a:pPr>
-              <a:defRPr sz="2400" b="1">
+              <a:defRPr sz="2300" b="1">
                 <a:solidFill>
                   <a:srgbClr val="0F172A"/>
                 </a:solidFill>
               </a:defRPr>
             </a:pPr>
             <a:r>
-              <a:t>二、解決方案：5D 校園多維治理與風險預警模型</a:t>
+              <a:t>項目一、解決方案說明：痛點與 5D 多維治理模型</a:t>
             </a:r>
           </a:p>
         </p:txBody>
@@ -4245,14 +4463,14 @@
           <a:lstStyle/>
           <a:p>
             <a:pPr>
-              <a:defRPr sz="1800" b="1">
-                <a:solidFill>
-                  <a:srgbClr val="2563EB"/>
-                </a:solidFill>
-              </a:defRPr>
-            </a:pPr>
-            <a:r>
-              <a:t>🎯 獨創「5D 校園治理全景指標」</a:t>
+              <a:defRPr sz="1700" b="1">
+                <a:solidFill>
+                  <a:srgbClr val="DC2626"/>
+                </a:solidFill>
+              </a:defRPr>
+            </a:pPr>
+            <a:r>
+              <a:t>🚨 現行校園與教保稽查三大瓶頸</a:t>
             </a:r>
           </a:p>
           <a:p>
@@ -4267,19 +4485,19 @@
               </a:defRPr>
             </a:pPr>
             <a:r>
-              <a:t>• 1. 裁罰法規違規維度：</a:t>
-            </a:r>
-          </a:p>
-          <a:p>
-            <a:pPr>
-              <a:defRPr sz="1200">
+              <a:t>• 1. 事後被動滅火：</a:t>
+            </a:r>
+          </a:p>
+          <a:p>
+            <a:pPr>
+              <a:defRPr sz="1100">
                 <a:solidFill>
                   <a:srgbClr val="64748B"/>
                 </a:solidFill>
               </a:defRPr>
             </a:pPr>
             <a:r>
-              <a:t>   跨年度重大裁罰、師生比超收、黑牌教保員累計記點</a:t>
+              <a:t>  傳統稽查高度仰賴家長事後申訴或重大案件爆發（如超收28人、未核備教保員、不當管教），孩童身心已受實質傷害，教育局疲於滅火。</a:t>
             </a:r>
           </a:p>
           <a:p>
@@ -4294,19 +4512,19 @@
               </a:defRPr>
             </a:pPr>
             <a:r>
-              <a:t>• 2. 班佛採購財務維度：</a:t>
-            </a:r>
-          </a:p>
-          <a:p>
-            <a:pPr>
-              <a:defRPr sz="1200">
+              <a:t>• 2. 局處資料孤島：</a:t>
+            </a:r>
+          </a:p>
+          <a:p>
+            <a:pPr>
+              <a:defRPr sz="1100">
                 <a:solidFill>
                   <a:srgbClr val="64748B"/>
                 </a:solidFill>
               </a:defRPr>
             </a:pPr>
             <a:r>
-              <a:t>   大宗食材與校舍修繕合約，導入 Benford's Law 假帳防弊</a:t>
+              <a:t>  裁罰歷程、食材登錄、採購標案、公安消防與 Google 評論散落各系統，未打通橫向勾稽，無法綜合研判隱性未爆彈。</a:t>
             </a:r>
           </a:p>
           <a:p>
@@ -4321,73 +4539,19 @@
               </a:defRPr>
             </a:pPr>
             <a:r>
-              <a:t>• 3. 社群負面輿情維度：</a:t>
-            </a:r>
-          </a:p>
-          <a:p>
-            <a:pPr>
-              <a:defRPr sz="1200">
+              <a:t>• 3. 稽查人力難以普查：</a:t>
+            </a:r>
+          </a:p>
+          <a:p>
+            <a:pPr>
+              <a:defRPr sz="1100">
                 <a:solidFill>
                   <a:srgbClr val="64748B"/>
                 </a:solidFill>
               </a:defRPr>
             </a:pPr>
             <a:r>
-              <a:t>   Google Places 公眾評價與家長社群投訴 NLP 情感分析</a:t>
-            </a:r>
-          </a:p>
-          <a:p>
-            <a:pPr>
-              <a:spcBef>
-                <a:spcPts val="800"/>
-              </a:spcBef>
-              <a:defRPr sz="1300" b="1">
-                <a:solidFill>
-                  <a:srgbClr val="0F172A"/>
-                </a:solidFill>
-              </a:defRPr>
-            </a:pPr>
-            <a:r>
-              <a:t>• 4. 師資異動流動維度：</a:t>
-            </a:r>
-          </a:p>
-          <a:p>
-            <a:pPr>
-              <a:defRPr sz="1200">
-                <a:solidFill>
-                  <a:srgbClr val="64748B"/>
-                </a:solidFill>
-              </a:defRPr>
-            </a:pPr>
-            <a:r>
-              <a:t>   核心師資頻繁離退、流動率異常、投保核備合規性監測</a:t>
-            </a:r>
-          </a:p>
-          <a:p>
-            <a:pPr>
-              <a:spcBef>
-                <a:spcPts val="800"/>
-              </a:spcBef>
-              <a:defRPr sz="1300" b="1">
-                <a:solidFill>
-                  <a:srgbClr val="0F172A"/>
-                </a:solidFill>
-              </a:defRPr>
-            </a:pPr>
-            <a:r>
-              <a:t>• 5. 環境公安食安維度：</a:t>
-            </a:r>
-          </a:p>
-          <a:p>
-            <a:pPr>
-              <a:defRPr sz="1200">
-                <a:solidFill>
-                  <a:srgbClr val="64748B"/>
-                </a:solidFill>
-              </a:defRPr>
-            </a:pPr>
-            <a:r>
-              <a:t>   校舍防墜設施檢驗合格證、午餐廚房留樣 48h 履歷</a:t>
+              <a:t>  新北 29 區逾 1,500 所學校與幼托，專任稽查員難以地毯式普查，急需 AI 智慧風險分流，精準打擊高風險機構。</a:t>
             </a:r>
           </a:p>
         </p:txBody>
@@ -4460,95 +4624,149 @@
           <a:lstStyle/>
           <a:p>
             <a:pPr>
-              <a:defRPr sz="1800" b="1">
+              <a:defRPr sz="1700" b="1">
+                <a:solidFill>
+                  <a:srgbClr val="2563EB"/>
+                </a:solidFill>
+              </a:defRPr>
+            </a:pPr>
+            <a:r>
+              <a:t>🎯 獨創「5D 校園多維治理指標模型」</a:t>
+            </a:r>
+          </a:p>
+          <a:p>
+            <a:pPr>
+              <a:spcBef>
+                <a:spcPts val="600"/>
+              </a:spcBef>
+              <a:defRPr sz="1200" b="1">
                 <a:solidFill>
                   <a:srgbClr val="0F172A"/>
                 </a:solidFill>
               </a:defRPr>
             </a:pPr>
             <a:r>
-              <a:t>🚦 智慧風險分級梯隊（新北 468 所實測）</a:t>
+              <a:t>✓ 1. 裁罰法規違規維度 (35%)：</a:t>
+            </a:r>
+          </a:p>
+          <a:p>
+            <a:pPr>
+              <a:defRPr sz="1100">
+                <a:solidFill>
+                  <a:srgbClr val="64748B"/>
+                </a:solidFill>
+              </a:defRPr>
+            </a:pPr>
+            <a:r>
+              <a:t>   累計違規處分字號、超收幼童人數、黑牌教保員記點</a:t>
             </a:r>
           </a:p>
           <a:p>
             <a:pPr>
               <a:spcBef>
-                <a:spcPts val="1000"/>
+                <a:spcPts val="600"/>
               </a:spcBef>
-              <a:defRPr sz="1400" b="1">
-                <a:solidFill>
-                  <a:srgbClr val="DC2626"/>
-                </a:solidFill>
-              </a:defRPr>
-            </a:pPr>
-            <a:r>
-              <a:t>🔴 第一級：高風險機構 (28 所 / 6%)</a:t>
-            </a:r>
-          </a:p>
-          <a:p>
-            <a:pPr>
-              <a:defRPr sz="1200">
+              <a:defRPr sz="1200" b="1">
+                <a:solidFill>
+                  <a:srgbClr val="0F172A"/>
+                </a:solidFill>
+              </a:defRPr>
+            </a:pPr>
+            <a:r>
+              <a:t>✓ 2. 班佛採購財務維度 (20%)：</a:t>
+            </a:r>
+          </a:p>
+          <a:p>
+            <a:pPr>
+              <a:defRPr sz="1100">
                 <a:solidFill>
                   <a:srgbClr val="64748B"/>
                 </a:solidFill>
               </a:defRPr>
             </a:pPr>
             <a:r>
-              <a:t>【重點突擊稽查】 評分 72~88 分。涉及重大超收（如超收 28 人遭罰 18 萬）、不當對待查證屬實或採購嚴重偏離班佛定律。教育局 3 日內派員現場突擊檢查。</a:t>
+              <a:t>   大宗食材與校舍修繕合約，導入 Benford's Law 假帳防弊</a:t>
             </a:r>
           </a:p>
           <a:p>
             <a:pPr>
               <a:spcBef>
-                <a:spcPts val="1000"/>
+                <a:spcPts val="600"/>
               </a:spcBef>
-              <a:defRPr sz="1400" b="1">
-                <a:solidFill>
-                  <a:srgbClr val="2563EB"/>
-                </a:solidFill>
-              </a:defRPr>
-            </a:pPr>
-            <a:r>
-              <a:t>🟡 第二級：中風險機構 (56 所 / 12%)</a:t>
-            </a:r>
-          </a:p>
-          <a:p>
-            <a:pPr>
-              <a:defRPr sz="1200">
+              <a:defRPr sz="1200" b="1">
+                <a:solidFill>
+                  <a:srgbClr val="0F172A"/>
+                </a:solidFill>
+              </a:defRPr>
+            </a:pPr>
+            <a:r>
+              <a:t>✓ 3. 社群負面輿情維度 (20%)：</a:t>
+            </a:r>
+          </a:p>
+          <a:p>
+            <a:pPr>
+              <a:defRPr sz="1100">
                 <a:solidFill>
                   <a:srgbClr val="64748B"/>
                 </a:solidFill>
               </a:defRPr>
             </a:pPr>
             <a:r>
-              <a:t>【重點抽查輔導】 評分 48~65 分。偶發行政申報延宕、防墜網微損限期修復、食材漏登。列入下學期優先抽檢。</a:t>
+              <a:t>   Google Places 公開評價與家長留言 NLP 情感分析</a:t>
             </a:r>
           </a:p>
           <a:p>
             <a:pPr>
               <a:spcBef>
-                <a:spcPts val="1000"/>
+                <a:spcPts val="600"/>
               </a:spcBef>
-              <a:defRPr sz="1400" b="1">
-                <a:solidFill>
-                  <a:srgbClr val="10B981"/>
-                </a:solidFill>
-              </a:defRPr>
-            </a:pPr>
-            <a:r>
-              <a:t>🟢 第三級：低風險機構 (384 所 / 82%)</a:t>
-            </a:r>
-          </a:p>
-          <a:p>
-            <a:pPr>
-              <a:defRPr sz="1200">
+              <a:defRPr sz="1200" b="1">
+                <a:solidFill>
+                  <a:srgbClr val="0F172A"/>
+                </a:solidFill>
+              </a:defRPr>
+            </a:pPr>
+            <a:r>
+              <a:t>✓ 4. 師資異動流動維度 (15%)：</a:t>
+            </a:r>
+          </a:p>
+          <a:p>
+            <a:pPr>
+              <a:defRPr sz="1100">
                 <a:solidFill>
                   <a:srgbClr val="64748B"/>
                 </a:solidFill>
               </a:defRPr>
             </a:pPr>
             <a:r>
-              <a:t>【常態例行備查】 評分 15~36 分。營運良好、各項食安與公安齊備之模範公私立學校。</a:t>
+              <a:t>   核心師資年度流動率異常、投保在職核備合規追蹤</a:t>
+            </a:r>
+          </a:p>
+          <a:p>
+            <a:pPr>
+              <a:spcBef>
+                <a:spcPts val="600"/>
+              </a:spcBef>
+              <a:defRPr sz="1200" b="1">
+                <a:solidFill>
+                  <a:srgbClr val="0F172A"/>
+                </a:solidFill>
+              </a:defRPr>
+            </a:pPr>
+            <a:r>
+              <a:t>✓ 5. 環境公安食安維度 (10%)：</a:t>
+            </a:r>
+          </a:p>
+          <a:p>
+            <a:pPr>
+              <a:defRPr sz="1100">
+                <a:solidFill>
+                  <a:srgbClr val="64748B"/>
+                </a:solidFill>
+              </a:defRPr>
+            </a:pPr>
+            <a:r>
+              <a:t>   校舍防墜設施檢驗合格證明、午餐廚房 48h 留樣履歷</a:t>
             </a:r>
           </a:p>
         </p:txBody>
@@ -4623,7 +4841,7 @@
         <p:spPr>
           <a:xfrm>
             <a:off x="731520" y="365760"/>
-            <a:ext cx="10698480" cy="365760"/>
+            <a:ext cx="10698480" cy="320040"/>
           </a:xfrm>
           <a:prstGeom prst="rect">
             <a:avLst/>
@@ -4644,7 +4862,7 @@
               </a:defRPr>
             </a:pPr>
             <a:r>
-              <a:t>AWS 黑客松競賽提案 ｜ 教育局命題：教保機構風險監測</a:t>
+              <a:t>AWS 黑客松競賽提案 ｜ 項目一 ｜ 解決方案說明</a:t>
             </a:r>
           </a:p>
         </p:txBody>
@@ -4658,7 +4876,7 @@
         <p:spPr>
           <a:xfrm>
             <a:off x="731520" y="640080"/>
-            <a:ext cx="10698480" cy="640080"/>
+            <a:ext cx="10698480" cy="594360"/>
           </a:xfrm>
           <a:prstGeom prst="rect">
             <a:avLst/>
@@ -4672,14 +4890,14 @@
           <a:lstStyle/>
           <a:p>
             <a:pPr>
-              <a:defRPr sz="2400" b="1">
+              <a:defRPr sz="2300" b="1">
                 <a:solidFill>
                   <a:srgbClr val="0F172A"/>
                 </a:solidFill>
               </a:defRPr>
             </a:pPr>
             <a:r>
-              <a:t>三、數據及資料運用 (Data Sources &amp; Methodology)</a:t>
+              <a:t>項目一、解決方案說明：新北市 468 所機構實測分級</a:t>
             </a:r>
           </a:p>
         </p:txBody>
@@ -4693,7 +4911,7 @@
         <p:spPr>
           <a:xfrm>
             <a:off x="731520" y="1645920"/>
-            <a:ext cx="5212080" cy="4389120"/>
+            <a:ext cx="3328416" cy="4389120"/>
           </a:xfrm>
           <a:prstGeom prst="roundRect">
             <a:avLst/>
@@ -4703,7 +4921,7 @@
           </a:solidFill>
           <a:ln w="15240">
             <a:solidFill>
-              <a:srgbClr val="E2E8F0"/>
+              <a:srgbClr val="DC2626"/>
             </a:solidFill>
           </a:ln>
         </p:spPr>
@@ -4737,8 +4955,8 @@
         </p:nvSpPr>
         <p:spPr>
           <a:xfrm>
-            <a:off x="960120" y="1874519"/>
-            <a:ext cx="4754880" cy="3931920"/>
+            <a:off x="914400" y="1828800"/>
+            <a:ext cx="2962656" cy="3931920"/>
           </a:xfrm>
           <a:prstGeom prst="rect">
             <a:avLst/>
@@ -4752,122 +4970,54 @@
           <a:lstStyle/>
           <a:p>
             <a:pPr>
-              <a:defRPr sz="1800" b="1">
-                <a:solidFill>
-                  <a:srgbClr val="2563EB"/>
-                </a:solidFill>
-              </a:defRPr>
-            </a:pPr>
-            <a:r>
-              <a:t>📥 四大多源異質官方數據匯流</a:t>
+              <a:defRPr sz="1600" b="1">
+                <a:solidFill>
+                  <a:srgbClr val="DC2626"/>
+                </a:solidFill>
+              </a:defRPr>
+            </a:pPr>
+            <a:r>
+              <a:t>🔴 第一級：高風險對象</a:t>
             </a:r>
           </a:p>
           <a:p>
             <a:pPr>
               <a:spcBef>
-                <a:spcPts val="800"/>
+                <a:spcPts val="600"/>
               </a:spcBef>
-              <a:defRPr sz="1300" b="1">
+              <a:defRPr sz="1100" b="1">
                 <a:solidFill>
                   <a:srgbClr val="0F172A"/>
                 </a:solidFill>
               </a:defRPr>
             </a:pPr>
             <a:r>
-              <a:t>✓ 教育部全國教保資訊網 API</a:t>
-            </a:r>
-          </a:p>
-          <a:p>
-            <a:pPr>
-              <a:defRPr sz="1200">
+              <a:t>28 所 (6%)  【處置：3 日內重點突擊稽查】</a:t>
+            </a:r>
+          </a:p>
+          <a:p>
+            <a:pPr>
+              <a:spcBef>
+                <a:spcPts val="1200"/>
+              </a:spcBef>
+              <a:defRPr sz="1100">
                 <a:solidFill>
                   <a:srgbClr val="64748B"/>
                 </a:solidFill>
               </a:defRPr>
             </a:pPr>
             <a:r>
-              <a:t>   串接全台幼托立案許可、核定收托人數、歷史違規處分字號與裁罰法條。</a:t>
-            </a:r>
-          </a:p>
-          <a:p>
-            <a:pPr>
-              <a:spcBef>
-                <a:spcPts val="800"/>
-              </a:spcBef>
-              <a:defRPr sz="1300" b="1">
-                <a:solidFill>
-                  <a:srgbClr val="0F172A"/>
-                </a:solidFill>
-              </a:defRPr>
-            </a:pPr>
-            <a:r>
-              <a:t>✓ 新北市政府開放資料平台 (NTPC Open Data)</a:t>
-            </a:r>
-          </a:p>
-          <a:p>
-            <a:pPr>
-              <a:defRPr sz="1200">
-                <a:solidFill>
-                  <a:srgbClr val="64748B"/>
-                </a:solidFill>
-              </a:defRPr>
-            </a:pPr>
-            <a:r>
-              <a:t>   整合新北 29 區公私立高中職、國中、國小校舍規模、學區與營養午餐合約。</a:t>
-            </a:r>
-          </a:p>
-          <a:p>
-            <a:pPr>
-              <a:spcBef>
-                <a:spcPts val="800"/>
-              </a:spcBef>
-              <a:defRPr sz="1300" b="1">
-                <a:solidFill>
-                  <a:srgbClr val="0F172A"/>
-                </a:solidFill>
-              </a:defRPr>
-            </a:pPr>
-            <a:r>
-              <a:t>✓ 行政院政府電子採購網 (e-Procurement)</a:t>
-            </a:r>
-          </a:p>
-          <a:p>
-            <a:pPr>
-              <a:defRPr sz="1200">
-                <a:solidFill>
-                  <a:srgbClr val="64748B"/>
-                </a:solidFill>
-              </a:defRPr>
-            </a:pPr>
-            <a:r>
-              <a:t>   抓取食材供應、設備採購與校舍防墜工程之招標決標金額（供防弊分析）。</a:t>
-            </a:r>
-          </a:p>
-          <a:p>
-            <a:pPr>
-              <a:spcBef>
-                <a:spcPts val="800"/>
-              </a:spcBef>
-              <a:defRPr sz="1300" b="1">
-                <a:solidFill>
-                  <a:srgbClr val="0F172A"/>
-                </a:solidFill>
-              </a:defRPr>
-            </a:pPr>
-            <a:r>
-              <a:t>✓ Google Places &amp; Maps API</a:t>
-            </a:r>
-          </a:p>
-          <a:p>
-            <a:pPr>
-              <a:defRPr sz="1200">
-                <a:solidFill>
-                  <a:srgbClr val="64748B"/>
-                </a:solidFill>
-              </a:defRPr>
-            </a:pPr>
-            <a:r>
-              <a:t>   採集家長真實評分（1~5星）、累積評論則數與最新留言文本。</a:t>
+              <a:t>評分區間：72 ~ 88 分</a:t>
+            </a:r>
+            <a:br/>
+            <a:br/>
+            <a:r>
+              <a:t>典型特徵：涉及重大違規超收（如超收 28 人重罰 18 萬）、不當管教查證屬實、班佛定律高度假帳警示。</a:t>
+            </a:r>
+            <a:br/>
+            <a:br/>
+            <a:r>
+              <a:t>局端行動：由 Bedrock 產出實地稽查清單，排定公安食安小組 3 日內無預警現場盤查。</a:t>
             </a:r>
           </a:p>
         </p:txBody>
@@ -4880,8 +5030,8 @@
         </p:nvSpPr>
         <p:spPr>
           <a:xfrm>
-            <a:off x="6217920" y="1645920"/>
-            <a:ext cx="5212080" cy="4389120"/>
+            <a:off x="4407408" y="1645920"/>
+            <a:ext cx="3328416" cy="4389120"/>
           </a:xfrm>
           <a:prstGeom prst="roundRect">
             <a:avLst/>
@@ -4891,7 +5041,7 @@
           </a:solidFill>
           <a:ln w="15240">
             <a:solidFill>
-              <a:srgbClr val="E2E8F0"/>
+              <a:srgbClr val="D97706"/>
             </a:solidFill>
           </a:ln>
         </p:spPr>
@@ -4925,8 +5075,8 @@
         </p:nvSpPr>
         <p:spPr>
           <a:xfrm>
-            <a:off x="6446520" y="1874519"/>
-            <a:ext cx="4754880" cy="3931920"/>
+            <a:off x="4590288" y="1828800"/>
+            <a:ext cx="2962656" cy="3931920"/>
           </a:xfrm>
           <a:prstGeom prst="rect">
             <a:avLst/>
@@ -4940,95 +5090,174 @@
           <a:lstStyle/>
           <a:p>
             <a:pPr>
-              <a:defRPr sz="1800" b="1">
+              <a:defRPr sz="1600" b="1">
+                <a:solidFill>
+                  <a:srgbClr val="D97706"/>
+                </a:solidFill>
+              </a:defRPr>
+            </a:pPr>
+            <a:r>
+              <a:t>🟡 第二級：中風險對象</a:t>
+            </a:r>
+          </a:p>
+          <a:p>
+            <a:pPr>
+              <a:spcBef>
+                <a:spcPts val="600"/>
+              </a:spcBef>
+              <a:defRPr sz="1100" b="1">
                 <a:solidFill>
                   <a:srgbClr val="0F172A"/>
                 </a:solidFill>
               </a:defRPr>
             </a:pPr>
             <a:r>
-              <a:t>⚙️ 核心演算法與模型架構</a:t>
+              <a:t>56 所 (12%)  【處置：次學期專案抽查輔導】</a:t>
             </a:r>
           </a:p>
           <a:p>
             <a:pPr>
               <a:spcBef>
-                <a:spcPts val="1000"/>
+                <a:spcPts val="1200"/>
               </a:spcBef>
-              <a:defRPr sz="1300" b="1">
-                <a:solidFill>
-                  <a:srgbClr val="2563EB"/>
-                </a:solidFill>
-              </a:defRPr>
-            </a:pPr>
-            <a:r>
-              <a:t>🔍 班佛定律 (Benford's Law) 財務異常檢定</a:t>
-            </a:r>
-          </a:p>
-          <a:p>
-            <a:pPr>
-              <a:defRPr sz="1200">
+              <a:defRPr sz="1100">
                 <a:solidFill>
                   <a:srgbClr val="64748B"/>
                 </a:solidFill>
               </a:defRPr>
             </a:pPr>
             <a:r>
-              <a:t>分析採購標案與代辦費金額首位數字機率分佈 P(d)=log10(1+1/d)。若卡方檢定 p-value &lt; 0.05 且首位集中於特定數字，自動觸發人為假帳與拆單防弊告警。</a:t>
+              <a:t>評分區間：48 ~ 65 分</a:t>
+            </a:r>
+            <a:br/>
+            <a:br/>
+            <a:r>
+              <a:t>典型特徵：偶發行政申報延宕、防墜設施微損限期改善、食材登錄漏填、評論出現負向關鍵字。</a:t>
+            </a:r>
+            <a:br/>
+            <a:br/>
+            <a:r>
+              <a:t>局端行動：列入輔導名單，限期 30 天上傳改善照片，並排定次學期優先抽檢。</a:t>
+            </a:r>
+          </a:p>
+        </p:txBody>
+      </p:sp>
+      <p:sp>
+        <p:nvSpPr>
+          <p:cNvPr id="9" name="Rounded Rectangle 8"/>
+          <p:cNvSpPr/>
+          <p:nvPr/>
+        </p:nvSpPr>
+        <p:spPr>
+          <a:xfrm>
+            <a:off x="8083296" y="1645920"/>
+            <a:ext cx="3328416" cy="4389120"/>
+          </a:xfrm>
+          <a:prstGeom prst="roundRect">
+            <a:avLst/>
+          </a:prstGeom>
+          <a:solidFill>
+            <a:srgbClr val="FFFFFF"/>
+          </a:solidFill>
+          <a:ln w="15240">
+            <a:solidFill>
+              <a:srgbClr val="10B981"/>
+            </a:solidFill>
+          </a:ln>
+        </p:spPr>
+        <p:style>
+          <a:lnRef idx="1">
+            <a:schemeClr val="accent1"/>
+          </a:lnRef>
+          <a:fillRef idx="3">
+            <a:schemeClr val="accent1"/>
+          </a:fillRef>
+          <a:effectRef idx="2">
+            <a:schemeClr val="accent1"/>
+          </a:effectRef>
+          <a:fontRef idx="minor">
+            <a:schemeClr val="lt1"/>
+          </a:fontRef>
+        </p:style>
+        <p:txBody>
+          <a:bodyPr rtlCol="0" anchor="ctr"/>
+          <a:lstStyle/>
+          <a:p>
+            <a:pPr algn="ctr"/>
+          </a:p>
+        </p:txBody>
+      </p:sp>
+      <p:sp>
+        <p:nvSpPr>
+          <p:cNvPr id="10" name="TextBox 9"/>
+          <p:cNvSpPr txBox="1"/>
+          <p:nvPr/>
+        </p:nvSpPr>
+        <p:spPr>
+          <a:xfrm>
+            <a:off x="8266176" y="1828800"/>
+            <a:ext cx="2962656" cy="3931920"/>
+          </a:xfrm>
+          <a:prstGeom prst="rect">
+            <a:avLst/>
+          </a:prstGeom>
+          <a:noFill/>
+        </p:spPr>
+        <p:txBody>
+          <a:bodyPr wrap="square">
+            <a:spAutoFit/>
+          </a:bodyPr>
+          <a:lstStyle/>
+          <a:p>
+            <a:pPr>
+              <a:defRPr sz="1600" b="1">
+                <a:solidFill>
+                  <a:srgbClr val="10B981"/>
+                </a:solidFill>
+              </a:defRPr>
+            </a:pPr>
+            <a:r>
+              <a:t>🟢 第三級：低風險對象</a:t>
             </a:r>
           </a:p>
           <a:p>
             <a:pPr>
               <a:spcBef>
-                <a:spcPts val="1000"/>
+                <a:spcPts val="600"/>
               </a:spcBef>
-              <a:defRPr sz="1300" b="1">
-                <a:solidFill>
-                  <a:srgbClr val="2563EB"/>
-                </a:solidFill>
-              </a:defRPr>
-            </a:pPr>
-            <a:r>
-              <a:t>🔍 多因子動態風險評估權重模型</a:t>
-            </a:r>
-          </a:p>
-          <a:p>
-            <a:pPr>
-              <a:defRPr sz="1200">
+              <a:defRPr sz="1100" b="1">
+                <a:solidFill>
+                  <a:srgbClr val="0F172A"/>
+                </a:solidFill>
+              </a:defRPr>
+            </a:pPr>
+            <a:r>
+              <a:t>384 所 (82%)  【處置：常態例行自主備查】</a:t>
+            </a:r>
+          </a:p>
+          <a:p>
+            <a:pPr>
+              <a:spcBef>
+                <a:spcPts val="1200"/>
+              </a:spcBef>
+              <a:defRPr sz="1100">
                 <a:solidFill>
                   <a:srgbClr val="64748B"/>
                 </a:solidFill>
               </a:defRPr>
             </a:pPr>
             <a:r>
-              <a:t>綜合治理指數 = 裁罰違規 (35%) + 班佛財務 (20%) + 輿情情感 (20%) + 師生比合規 (15%) + 安全設施 (10%)，動態量化為 0~100 風險分。</a:t>
-            </a:r>
-          </a:p>
-          <a:p>
-            <a:pPr>
-              <a:spcBef>
-                <a:spcPts val="1000"/>
-              </a:spcBef>
-              <a:defRPr sz="1300" b="1">
-                <a:solidFill>
-                  <a:srgbClr val="2563EB"/>
-                </a:solidFill>
-              </a:defRPr>
-            </a:pPr>
-            <a:r>
-              <a:t>🔍 NLP 負面情感與違規關鍵字探勘</a:t>
-            </a:r>
-          </a:p>
-          <a:p>
-            <a:pPr>
-              <a:defRPr sz="1200">
-                <a:solidFill>
-                  <a:srgbClr val="64748B"/>
-                </a:solidFill>
-              </a:defRPr>
-            </a:pPr>
-            <a:r>
-              <a:t>自動比對「超收、體罰、推搡、未核備、拉肚子、髒亂」等負向詞彙，提早發掘隱性家長不滿。</a:t>
+              <a:t>評分區間：15 ~ 36 分</a:t>
+            </a:r>
+            <a:br/>
+            <a:br/>
+            <a:r>
+              <a:t>典型特徵：營運良好、各項食安公安登錄完整、防墜驗證齊備、家長網路社群正面評價高。</a:t>
+            </a:r>
+            <a:br/>
+            <a:br/>
+            <a:r>
+              <a:t>局端行動：常態線上書面備查，大幅釋放稽查人力，將公務能量聚焦於高風險未爆彈。</a:t>
             </a:r>
           </a:p>
         </p:txBody>
@@ -5103,7 +5332,7 @@
         <p:spPr>
           <a:xfrm>
             <a:off x="731520" y="365760"/>
-            <a:ext cx="10698480" cy="365760"/>
+            <a:ext cx="10698480" cy="320040"/>
           </a:xfrm>
           <a:prstGeom prst="rect">
             <a:avLst/>
@@ -5124,7 +5353,7 @@
               </a:defRPr>
             </a:pPr>
             <a:r>
-              <a:t>AWS 黑客松競賽提案 ｜ 教育局命題：教保機構風險監測</a:t>
+              <a:t>AWS 黑客松競賽提案 ｜ 項目二 ｜ 數據及資料運用</a:t>
             </a:r>
           </a:p>
         </p:txBody>
@@ -5138,7 +5367,7 @@
         <p:spPr>
           <a:xfrm>
             <a:off x="731520" y="640080"/>
-            <a:ext cx="10698480" cy="640080"/>
+            <a:ext cx="10698480" cy="594360"/>
           </a:xfrm>
           <a:prstGeom prst="rect">
             <a:avLst/>
@@ -5152,14 +5381,14 @@
           <a:lstStyle/>
           <a:p>
             <a:pPr>
-              <a:defRPr sz="2400" b="1">
+              <a:defRPr sz="2300" b="1">
                 <a:solidFill>
                   <a:srgbClr val="0F172A"/>
                 </a:solidFill>
               </a:defRPr>
             </a:pPr>
             <a:r>
-              <a:t>四、AWS 雲端技術架構 (AWS Cloud Architecture)</a:t>
+              <a:t>項目二、數據及資料運用：4 大數據源與防弊演算法</a:t>
             </a:r>
           </a:p>
         </p:txBody>
@@ -5173,7 +5402,7 @@
         <p:spPr>
           <a:xfrm>
             <a:off x="731520" y="1645920"/>
-            <a:ext cx="5669280" cy="4389120"/>
+            <a:ext cx="5212080" cy="4389120"/>
           </a:xfrm>
           <a:prstGeom prst="roundRect">
             <a:avLst/>
@@ -5217,8 +5446,8 @@
         </p:nvSpPr>
         <p:spPr>
           <a:xfrm>
-            <a:off x="960120" y="1828800"/>
-            <a:ext cx="5212080" cy="4023360"/>
+            <a:off x="960120" y="1874519"/>
+            <a:ext cx="4754880" cy="3931920"/>
           </a:xfrm>
           <a:prstGeom prst="rect">
             <a:avLst/>
@@ -5239,123 +5468,115 @@
               </a:defRPr>
             </a:pPr>
             <a:r>
-              <a:t>🏛️ AWS 全端雲端拓撲架構圖</a:t>
+              <a:t>📥 四大多源異質官方數據前處理</a:t>
             </a:r>
           </a:p>
           <a:p>
             <a:pPr>
               <a:spcBef>
-                <a:spcPts val="400"/>
+                <a:spcPts val="800"/>
               </a:spcBef>
-              <a:defRPr sz="950">
+              <a:defRPr sz="1200" b="1">
                 <a:solidFill>
                   <a:srgbClr val="0F172A"/>
                 </a:solidFill>
-                <a:latin typeface="Consolas"/>
-              </a:defRPr>
-            </a:pPr>
-            <a:r>
-              <a:t>[ 使用者 / 家長 / 教育局官員 ]</a:t>
-            </a:r>
-            <a:br/>
-            <a:r>
-              <a:t>       │ (HTTPS 443 傳輸)</a:t>
-            </a:r>
-            <a:br/>
-            <a:r>
-              <a:t>       ▼</a:t>
-            </a:r>
-            <a:br/>
-            <a:r>
-              <a:t>┌────────────────────────────────────────┐</a:t>
-            </a:r>
-            <a:br/>
-            <a:r>
-              <a:t>│ Amazon CloudFront (全球 CDN + AWS WAF) │ (唯一公開入口)</a:t>
-            </a:r>
-            <a:br/>
-            <a:r>
-              <a:t>└───────────────┬────────────────────────┘</a:t>
-            </a:r>
-            <a:br/>
-            <a:r>
-              <a:t>                │</a:t>
-            </a:r>
-            <a:br/>
-            <a:r>
-              <a:t>     ┌──────────┴──────────┐</a:t>
-            </a:r>
-            <a:br/>
-            <a:r>
-              <a:t>(靜態 SPA)                 │ (API: /api/*)</a:t>
-            </a:r>
-            <a:br/>
-            <a:r>
-              <a:t>     ▼                     ▼</a:t>
-            </a:r>
-            <a:br/>
-            <a:r>
-              <a:t>┌──────────────┐   ┌───────────────────────────┐</a:t>
-            </a:r>
-            <a:br/>
-            <a:r>
-              <a:t>│  Amazon S3   │   │ Application Load Balancer │</a:t>
-            </a:r>
-            <a:br/>
-            <a:r>
-              <a:t>│ (Block Public│   └─────────────┬─────────────┘</a:t>
-            </a:r>
-            <a:br/>
-            <a:r>
-              <a:t>│  Access 開啟)│                 │ (私有 VPC 轉發)</a:t>
-            </a:r>
-            <a:br/>
-            <a:r>
-              <a:t>│ 透過 OAC 授權│                 ▼</a:t>
-            </a:r>
-            <a:br/>
-            <a:r>
-              <a:t>└──────────────┘   ┌───────────────────────────┐</a:t>
-            </a:r>
-            <a:br/>
-            <a:r>
-              <a:t>                   │ Amazon ECS Fargate 容器   │ (FastAPI 後端)</a:t>
-            </a:r>
-            <a:br/>
-            <a:r>
-              <a:t>                   └───────┬───────────┬───────┘</a:t>
-            </a:r>
-            <a:br/>
-            <a:r>
-              <a:t>                           │           │</a:t>
-            </a:r>
-            <a:br/>
-            <a:r>
-              <a:t>            ┌──────────────┘           └──────────────┐</a:t>
-            </a:r>
-            <a:br/>
-            <a:r>
-              <a:t>            ▼                                         ▼</a:t>
-            </a:r>
-            <a:br/>
-            <a:r>
-              <a:t>┌─────────────────────────┐               ┌─────────────────────────┐</a:t>
-            </a:r>
-            <a:br/>
-            <a:r>
-              <a:t>│ Amazon Aurora RDS (Postgre)              │ Amazon Bedrock (Claude) │</a:t>
-            </a:r>
-            <a:br/>
-            <a:r>
-              <a:t>│ (Private Subnet, 禁公開存取)              │ (嚴格限流: RPS &lt;= 1)    │</a:t>
-            </a:r>
-            <a:br/>
-            <a:r>
-              <a:t>│ 儲存新北 468 所校園完整數據              │ 自動產出突擊稽查指示書   │</a:t>
-            </a:r>
-            <a:br/>
-            <a:r>
-              <a:t>└─────────────────────────┘               └─────────────────────────┘</a:t>
+              </a:defRPr>
+            </a:pPr>
+            <a:r>
+              <a:t>✓ 教育部全國教保資訊網 API</a:t>
+            </a:r>
+          </a:p>
+          <a:p>
+            <a:pPr>
+              <a:defRPr sz="1100">
+                <a:solidFill>
+                  <a:srgbClr val="64748B"/>
+                </a:solidFill>
+              </a:defRPr>
+            </a:pPr>
+            <a:r>
+              <a:t>   串接幼托立案許可、核定收托名額、歷史違規處分字號與違反法條。</a:t>
+            </a:r>
+          </a:p>
+          <a:p>
+            <a:pPr>
+              <a:spcBef>
+                <a:spcPts val="800"/>
+              </a:spcBef>
+              <a:defRPr sz="1200" b="1">
+                <a:solidFill>
+                  <a:srgbClr val="0F172A"/>
+                </a:solidFill>
+              </a:defRPr>
+            </a:pPr>
+            <a:r>
+              <a:t>✓ 新北市政府開放資料平台 (NTPC Open Data)</a:t>
+            </a:r>
+          </a:p>
+          <a:p>
+            <a:pPr>
+              <a:defRPr sz="1100">
+                <a:solidFill>
+                  <a:srgbClr val="64748B"/>
+                </a:solidFill>
+              </a:defRPr>
+            </a:pPr>
+            <a:r>
+              <a:t>   整合新北 29 區公私立高中職、國中、國小規模、學區與午餐合約。</a:t>
+            </a:r>
+          </a:p>
+          <a:p>
+            <a:pPr>
+              <a:spcBef>
+                <a:spcPts val="800"/>
+              </a:spcBef>
+              <a:defRPr sz="1200" b="1">
+                <a:solidFill>
+                  <a:srgbClr val="0F172A"/>
+                </a:solidFill>
+              </a:defRPr>
+            </a:pPr>
+            <a:r>
+              <a:t>✓ 行政院政府電子採購網 (e-Procurement)</a:t>
+            </a:r>
+          </a:p>
+          <a:p>
+            <a:pPr>
+              <a:defRPr sz="1100">
+                <a:solidFill>
+                  <a:srgbClr val="64748B"/>
+                </a:solidFill>
+              </a:defRPr>
+            </a:pPr>
+            <a:r>
+              <a:t>   擷取食材供應、設備採購與校舍防墜工程之招標決標金額（供防弊分析）。</a:t>
+            </a:r>
+          </a:p>
+          <a:p>
+            <a:pPr>
+              <a:spcBef>
+                <a:spcPts val="800"/>
+              </a:spcBef>
+              <a:defRPr sz="1200" b="1">
+                <a:solidFill>
+                  <a:srgbClr val="0F172A"/>
+                </a:solidFill>
+              </a:defRPr>
+            </a:pPr>
+            <a:r>
+              <a:t>✓ Google Places &amp; Maps API</a:t>
+            </a:r>
+          </a:p>
+          <a:p>
+            <a:pPr>
+              <a:defRPr sz="1100">
+                <a:solidFill>
+                  <a:srgbClr val="64748B"/>
+                </a:solidFill>
+              </a:defRPr>
+            </a:pPr>
+            <a:r>
+              <a:t>   採集家長真實評分（1~5星）、評論則數與最新留言文本進行 NLP 探勘。</a:t>
             </a:r>
           </a:p>
         </p:txBody>
@@ -5368,8 +5589,8 @@
         </p:nvSpPr>
         <p:spPr>
           <a:xfrm>
-            <a:off x="6675120" y="1645920"/>
-            <a:ext cx="4754880" cy="4389120"/>
+            <a:off x="6217920" y="1645920"/>
+            <a:ext cx="5212080" cy="4389120"/>
           </a:xfrm>
           <a:prstGeom prst="roundRect">
             <a:avLst/>
@@ -5413,8 +5634,8 @@
         </p:nvSpPr>
         <p:spPr>
           <a:xfrm>
-            <a:off x="6903720" y="1874519"/>
-            <a:ext cx="4297680" cy="3931920"/>
+            <a:off x="6446520" y="1874519"/>
+            <a:ext cx="4754880" cy="3931920"/>
           </a:xfrm>
           <a:prstGeom prst="rect">
             <a:avLst/>
@@ -5435,22 +5656,22 @@
               </a:defRPr>
             </a:pPr>
             <a:r>
-              <a:t>🛡️ 100% 恪遵大會安全規範檢核</a:t>
+              <a:t>⚙️ 核心防弊演算法與量化模型</a:t>
             </a:r>
           </a:p>
           <a:p>
             <a:pPr>
               <a:spcBef>
-                <a:spcPts val="600"/>
+                <a:spcPts val="800"/>
               </a:spcBef>
               <a:defRPr sz="1200" b="1">
                 <a:solidFill>
-                  <a:srgbClr val="0F172A"/>
-                </a:solidFill>
-              </a:defRPr>
-            </a:pPr>
-            <a:r>
-              <a:t>✅ 1. S3 阻斷公開存取 (Block Public Access)</a:t>
+                  <a:srgbClr val="2563EB"/>
+                </a:solidFill>
+              </a:defRPr>
+            </a:pPr>
+            <a:r>
+              <a:t>🔍 班佛定律 (Benford's Law) 財務異常檢定</a:t>
             </a:r>
           </a:p>
           <a:p>
@@ -5462,22 +5683,22 @@
               </a:defRPr>
             </a:pPr>
             <a:r>
-              <a:t>符合規範第 1 條，S3 關閉所有公網存取，僅允許 CloudFront 透過 OAC 憑證讀取靜態網頁。</a:t>
+              <a:t>分析採購標案金額首位數字機率分佈 P(d)=log10(1+1/d)。若卡方檢定 p-value &lt; 0.05 且首位反常集中於特定數字，自動觸發人為假帳與刻意拆單防弊告警。</a:t>
             </a:r>
           </a:p>
           <a:p>
             <a:pPr>
               <a:spcBef>
-                <a:spcPts val="600"/>
+                <a:spcPts val="800"/>
               </a:spcBef>
               <a:defRPr sz="1200" b="1">
                 <a:solidFill>
-                  <a:srgbClr val="0F172A"/>
-                </a:solidFill>
-              </a:defRPr>
-            </a:pPr>
-            <a:r>
-              <a:t>✅ 2. 部署於指定主要區域 (Region)</a:t>
+                  <a:srgbClr val="2563EB"/>
+                </a:solidFill>
+              </a:defRPr>
+            </a:pPr>
+            <a:r>
+              <a:t>🔍 多因子動態風險指數綜合評估模型</a:t>
             </a:r>
           </a:p>
           <a:p>
@@ -5489,22 +5710,22 @@
               </a:defRPr>
             </a:pPr>
             <a:r>
-              <a:t>符合規範第 6 條，統一規劃部署於 AWS us-west-2 (Oregon) 區域。</a:t>
+              <a:t>綜合治理指數 = 裁罰 (35%) + 班佛 (20%) + 輿情 (20%) + 師生比 (15%) + 公安 (10%)，動態量化為 0~100 風險分。</a:t>
             </a:r>
           </a:p>
           <a:p>
             <a:pPr>
               <a:spcBef>
-                <a:spcPts val="600"/>
+                <a:spcPts val="800"/>
               </a:spcBef>
               <a:defRPr sz="1200" b="1">
                 <a:solidFill>
-                  <a:srgbClr val="0F172A"/>
-                </a:solidFill>
-              </a:defRPr>
-            </a:pPr>
-            <a:r>
-              <a:t>✅ 3. 零敏感個資安全政策 (No PII)</a:t>
+                  <a:srgbClr val="2563EB"/>
+                </a:solidFill>
+              </a:defRPr>
+            </a:pPr>
+            <a:r>
+              <a:t>🔍 NLP 負面情感與違規關鍵字探勘</a:t>
             </a:r>
           </a:p>
           <a:p>
@@ -5516,61 +5737,7 @@
               </a:defRPr>
             </a:pPr>
             <a:r>
-              <a:t>符合規範第 2 條，僅收錄政府公開之機構立案、公告處分與公開評價，零個人隱私資料。</a:t>
-            </a:r>
-          </a:p>
-          <a:p>
-            <a:pPr>
-              <a:spcBef>
-                <a:spcPts val="600"/>
-              </a:spcBef>
-              <a:defRPr sz="1200" b="1">
-                <a:solidFill>
-                  <a:srgbClr val="0F172A"/>
-                </a:solidFill>
-              </a:defRPr>
-            </a:pPr>
-            <a:r>
-              <a:t>✅ 4. RDS 關閉公開存取 (Private DB)</a:t>
-            </a:r>
-          </a:p>
-          <a:p>
-            <a:pPr>
-              <a:defRPr sz="1100">
-                <a:solidFill>
-                  <a:srgbClr val="64748B"/>
-                </a:solidFill>
-              </a:defRPr>
-            </a:pPr>
-            <a:r>
-              <a:t>符合規範第 4 條，Aurora 資料庫封裝於 VPC 私有子網，Security Group 嚴禁對外暴露。</a:t>
-            </a:r>
-          </a:p>
-          <a:p>
-            <a:pPr>
-              <a:spcBef>
-                <a:spcPts val="600"/>
-              </a:spcBef>
-              <a:defRPr sz="1200" b="1">
-                <a:solidFill>
-                  <a:srgbClr val="0F172A"/>
-                </a:solidFill>
-              </a:defRPr>
-            </a:pPr>
-            <a:r>
-              <a:t>✅ 5. Amazon Bedrock 嚴格限流 (RPS &lt;= 1)</a:t>
-            </a:r>
-          </a:p>
-          <a:p>
-            <a:pPr>
-              <a:defRPr sz="1100">
-                <a:solidFill>
-                  <a:srgbClr val="64748B"/>
-                </a:solidFill>
-              </a:defRPr>
-            </a:pPr>
-            <a:r>
-              <a:t>符合 Bedrock 規範第 1 條，呼叫內建 Token Bucket 節流演算法，請求嚴格控制在每秒 1 次以下。</a:t>
+              <a:t>自動比對「超收、體罰、推搡、未核備、拉肚子、髒亂」等負向關鍵詞，提早發掘隱性家長投訴不滿。</a:t>
             </a:r>
           </a:p>
         </p:txBody>
@@ -5645,7 +5812,7 @@
         <p:spPr>
           <a:xfrm>
             <a:off x="731520" y="365760"/>
-            <a:ext cx="10698480" cy="365760"/>
+            <a:ext cx="10698480" cy="320040"/>
           </a:xfrm>
           <a:prstGeom prst="rect">
             <a:avLst/>
@@ -5666,7 +5833,7 @@
               </a:defRPr>
             </a:pPr>
             <a:r>
-              <a:t>AWS 黑客松競賽提案 ｜ 教育局命題：教保機構風險監測</a:t>
+              <a:t>AWS 黑客松競賽提案 ｜ 項目三 ｜ AWS 雲端技術架構 (架構圖)</a:t>
             </a:r>
           </a:p>
         </p:txBody>
@@ -5680,7 +5847,7 @@
         <p:spPr>
           <a:xfrm>
             <a:off x="731520" y="640080"/>
-            <a:ext cx="10698480" cy="640080"/>
+            <a:ext cx="10698480" cy="594360"/>
           </a:xfrm>
           <a:prstGeom prst="rect">
             <a:avLst/>
@@ -5694,14 +5861,14 @@
           <a:lstStyle/>
           <a:p>
             <a:pPr>
-              <a:defRPr sz="2400" b="1">
+              <a:defRPr sz="2300" b="1">
                 <a:solidFill>
                   <a:srgbClr val="0F172A"/>
                 </a:solidFill>
               </a:defRPr>
             </a:pPr>
             <a:r>
-              <a:t>五、解決方案使用介面 (User Interface: GIS &amp; Directory)</a:t>
+              <a:t>項目三、AWS 雲端技術架構：全端拓撲架構圖</a:t>
             </a:r>
           </a:p>
         </p:txBody>
@@ -5715,7 +5882,7 @@
         <p:spPr>
           <a:xfrm>
             <a:off x="731520" y="1645920"/>
-            <a:ext cx="5212080" cy="4389120"/>
+            <a:ext cx="5669280" cy="4389120"/>
           </a:xfrm>
           <a:prstGeom prst="roundRect">
             <a:avLst/>
@@ -5759,8 +5926,8 @@
         </p:nvSpPr>
         <p:spPr>
           <a:xfrm>
-            <a:off x="960120" y="1874519"/>
-            <a:ext cx="4754880" cy="3931920"/>
+            <a:off x="960120" y="1783080"/>
+            <a:ext cx="5212080" cy="4114800"/>
           </a:xfrm>
           <a:prstGeom prst="rect">
             <a:avLst/>
@@ -5774,122 +5941,134 @@
           <a:lstStyle/>
           <a:p>
             <a:pPr>
-              <a:defRPr sz="1800" b="1">
+              <a:defRPr sz="1600" b="1">
                 <a:solidFill>
                   <a:srgbClr val="2563EB"/>
                 </a:solidFill>
               </a:defRPr>
             </a:pPr>
             <a:r>
-              <a:t>🗺️ 新北 GIS 地理資訊熱點地圖</a:t>
+              <a:t>🏛️ AWS 全端雲端拓撲架構圖</a:t>
             </a:r>
           </a:p>
           <a:p>
             <a:pPr>
               <a:spcBef>
-                <a:spcPts val="1000"/>
+                <a:spcPts val="400"/>
               </a:spcBef>
-              <a:defRPr sz="1300" b="1">
+              <a:defRPr sz="919">
                 <a:solidFill>
                   <a:srgbClr val="0F172A"/>
                 </a:solidFill>
-              </a:defRPr>
-            </a:pPr>
-            <a:r>
-              <a:t>• 新北全境 29 行政區快選膠囊</a:t>
-            </a:r>
-          </a:p>
-          <a:p>
-            <a:pPr>
-              <a:defRPr sz="1200">
-                <a:solidFill>
-                  <a:srgbClr val="64748B"/>
-                </a:solidFill>
-              </a:defRPr>
-            </a:pPr>
-            <a:r>
-              <a:t>  支援板橋、新莊、中和、永和、淡水、林口等 29 區一鍵縮放聚焦。</a:t>
-            </a:r>
-          </a:p>
-          <a:p>
-            <a:pPr>
-              <a:spcBef>
-                <a:spcPts val="1000"/>
-              </a:spcBef>
-              <a:defRPr sz="1300" b="1">
-                <a:solidFill>
-                  <a:srgbClr val="0F172A"/>
-                </a:solidFill>
-              </a:defRPr>
-            </a:pPr>
-            <a:r>
-              <a:t>• 四大全學制維度自由切換</a:t>
-            </a:r>
-          </a:p>
-          <a:p>
-            <a:pPr>
-              <a:defRPr sz="1200">
-                <a:solidFill>
-                  <a:srgbClr val="64748B"/>
-                </a:solidFill>
-              </a:defRPr>
-            </a:pPr>
-            <a:r>
-              <a:t>  即時切換「全部學制」、「高中職」、「國中」、「國小」、「幼兒園」。</a:t>
-            </a:r>
-          </a:p>
-          <a:p>
-            <a:pPr>
-              <a:spcBef>
-                <a:spcPts val="1000"/>
-              </a:spcBef>
-              <a:defRPr sz="1300" b="1">
-                <a:solidFill>
-                  <a:srgbClr val="0F172A"/>
-                </a:solidFill>
-              </a:defRPr>
-            </a:pPr>
-            <a:r>
-              <a:t>• 風險等級色彩即時分流</a:t>
-            </a:r>
-          </a:p>
-          <a:p>
-            <a:pPr>
-              <a:defRPr sz="1200">
-                <a:solidFill>
-                  <a:srgbClr val="64748B"/>
-                </a:solidFill>
-              </a:defRPr>
-            </a:pPr>
-            <a:r>
-              <a:t>  紅標（高風險）、黃標（中風險）、綠標（合格優良）清晰標記。</a:t>
-            </a:r>
-          </a:p>
-          <a:p>
-            <a:pPr>
-              <a:spcBef>
-                <a:spcPts val="1000"/>
-              </a:spcBef>
-              <a:defRPr sz="1300" b="1">
-                <a:solidFill>
-                  <a:srgbClr val="0F172A"/>
-                </a:solidFill>
-              </a:defRPr>
-            </a:pPr>
-            <a:r>
-              <a:t>• 點擊彈出機構核心檔案卡</a:t>
-            </a:r>
-          </a:p>
-          <a:p>
-            <a:pPr>
-              <a:defRPr sz="1200">
-                <a:solidFill>
-                  <a:srgbClr val="64748B"/>
-                </a:solidFill>
-              </a:defRPr>
-            </a:pPr>
-            <a:r>
-              <a:t>  顯示評分、核定容量、食安合格狀態與真實聯絡電話。</a:t>
+                <a:latin typeface="Consolas"/>
+              </a:defRPr>
+            </a:pPr>
+            <a:r>
+              <a:t>[ 終端使用者 / 家長 / 教育局稽查官 ]</a:t>
+            </a:r>
+            <a:br/>
+            <a:r>
+              <a:t>       │ (HTTPS TLS 1.3 傳輸)</a:t>
+            </a:r>
+            <a:br/>
+            <a:r>
+              <a:t>       ▼</a:t>
+            </a:r>
+            <a:br/>
+            <a:r>
+              <a:t>┌──────────────────────────────────────────────┐</a:t>
+            </a:r>
+            <a:br/>
+            <a:r>
+              <a:t>│ Amazon CloudFront (全球 CDN + AWS WAF 防火牆)│ (唯一公開對外入口)</a:t>
+            </a:r>
+            <a:br/>
+            <a:r>
+              <a:t>└───────────────┬──────────────────────────────┘</a:t>
+            </a:r>
+            <a:br/>
+            <a:r>
+              <a:t>                │</a:t>
+            </a:r>
+            <a:br/>
+            <a:r>
+              <a:t>     ┌──────────┴──────────┐</a:t>
+            </a:r>
+            <a:br/>
+            <a:r>
+              <a:t>(靜態 SPA 前端)            │ (動態 API: /api/*)</a:t>
+            </a:r>
+            <a:br/>
+            <a:r>
+              <a:t>     ▼                     ▼</a:t>
+            </a:r>
+            <a:br/>
+            <a:r>
+              <a:t>┌──────────────┐   ┌───────────────────────────┐</a:t>
+            </a:r>
+            <a:br/>
+            <a:r>
+              <a:t>│  Amazon S3   │   │ Application Load Balancer │</a:t>
+            </a:r>
+            <a:br/>
+            <a:r>
+              <a:t>│ (Block Public│   └─────────────┬─────────────┘</a:t>
+            </a:r>
+            <a:br/>
+            <a:r>
+              <a:t>│  Access 開啟)│                 │ (私有 VPC 路由)</a:t>
+            </a:r>
+            <a:br/>
+            <a:r>
+              <a:t>│ 透過 OAC 授權│                 ▼</a:t>
+            </a:r>
+            <a:br/>
+            <a:r>
+              <a:t>└──────────────┘   ┌───────────────────────────┐</a:t>
+            </a:r>
+            <a:br/>
+            <a:r>
+              <a:t>                   │ Amazon ECS Fargate 容器叢集│ (FastAPI 後端)</a:t>
+            </a:r>
+            <a:br/>
+            <a:r>
+              <a:t>                   └───────┬───────────┬───────┘</a:t>
+            </a:r>
+            <a:br/>
+            <a:r>
+              <a:t>                           │           │</a:t>
+            </a:r>
+            <a:br/>
+            <a:r>
+              <a:t>            ┌──────────────┘           └──────────────┐</a:t>
+            </a:r>
+            <a:br/>
+            <a:r>
+              <a:t>            ▼                                         ▼</a:t>
+            </a:r>
+            <a:br/>
+            <a:r>
+              <a:t>┌─────────────────────────┐               ┌─────────────────────────┐</a:t>
+            </a:r>
+            <a:br/>
+            <a:r>
+              <a:t>│ Amazon Aurora RDS       │               │ Amazon Bedrock          │</a:t>
+            </a:r>
+            <a:br/>
+            <a:r>
+              <a:t>│ (PostgreSQL 引擎)       │               │ (Claude 3.5 Sonnet 模型)│</a:t>
+            </a:r>
+            <a:br/>
+            <a:r>
+              <a:t>│ (Private Subnet 禁外網) │               │ (嚴格限流: RPS &lt;= 1)    │</a:t>
+            </a:r>
+            <a:br/>
+            <a:r>
+              <a:t>│ 儲存新北 468 所校園數據  │               │ 自動產出突擊稽查指示手冊│</a:t>
+            </a:r>
+            <a:br/>
+            <a:r>
+              <a:t>└─────────────────────────┘               └─────────────────────────┘</a:t>
             </a:r>
           </a:p>
         </p:txBody>
@@ -5902,8 +6081,8 @@
         </p:nvSpPr>
         <p:spPr>
           <a:xfrm>
-            <a:off x="6217920" y="1645920"/>
-            <a:ext cx="5212080" cy="4389120"/>
+            <a:off x="6675120" y="1645920"/>
+            <a:ext cx="4754880" cy="4389120"/>
           </a:xfrm>
           <a:prstGeom prst="roundRect">
             <a:avLst/>
@@ -5947,8 +6126,8 @@
         </p:nvSpPr>
         <p:spPr>
           <a:xfrm>
-            <a:off x="6446520" y="1874519"/>
-            <a:ext cx="4754880" cy="3931920"/>
+            <a:off x="6903720" y="1874519"/>
+            <a:ext cx="4297680" cy="3931920"/>
           </a:xfrm>
           <a:prstGeom prst="rect">
             <a:avLst/>
@@ -5962,122 +6141,149 @@
           <a:lstStyle/>
           <a:p>
             <a:pPr>
-              <a:defRPr sz="1800" b="1">
+              <a:defRPr sz="1600" b="1">
+                <a:solidFill>
+                  <a:srgbClr val="10B981"/>
+                </a:solidFill>
+              </a:defRPr>
+            </a:pPr>
+            <a:r>
+              <a:t>🛡️ 100% 恪遵大會安全規範檢核</a:t>
+            </a:r>
+          </a:p>
+          <a:p>
+            <a:pPr>
+              <a:spcBef>
+                <a:spcPts val="600"/>
+              </a:spcBef>
+              <a:defRPr sz="1200" b="1">
                 <a:solidFill>
                   <a:srgbClr val="0F172A"/>
                 </a:solidFill>
               </a:defRPr>
             </a:pPr>
             <a:r>
-              <a:t>📋 機構治理名冊與 5D 抽屜詳情</a:t>
+              <a:t>✅ 1. S3 阻斷公用存取 (Block Public Access)</a:t>
+            </a:r>
+          </a:p>
+          <a:p>
+            <a:pPr>
+              <a:defRPr sz="1050">
+                <a:solidFill>
+                  <a:srgbClr val="64748B"/>
+                </a:solidFill>
+              </a:defRPr>
+            </a:pPr>
+            <a:r>
+              <a:t>S3 關閉所有公用存取，僅允許 CloudFront 透過 OAC 憑證讀取。</a:t>
             </a:r>
           </a:p>
           <a:p>
             <a:pPr>
               <a:spcBef>
-                <a:spcPts val="1000"/>
+                <a:spcPts val="600"/>
               </a:spcBef>
-              <a:defRPr sz="1300" b="1">
-                <a:solidFill>
-                  <a:srgbClr val="2563EB"/>
-                </a:solidFill>
-              </a:defRPr>
-            </a:pPr>
-            <a:r>
-              <a:t>• 全方位多維複合篩選列</a:t>
-            </a:r>
-          </a:p>
-          <a:p>
-            <a:pPr>
-              <a:defRPr sz="1200">
+              <a:defRPr sz="1200" b="1">
+                <a:solidFill>
+                  <a:srgbClr val="0F172A"/>
+                </a:solidFill>
+              </a:defRPr>
+            </a:pPr>
+            <a:r>
+              <a:t>✅ 2. 零個人敏感個資安全政策 (No PII)</a:t>
+            </a:r>
+          </a:p>
+          <a:p>
+            <a:pPr>
+              <a:defRPr sz="1050">
                 <a:solidFill>
                   <a:srgbClr val="64748B"/>
                 </a:solidFill>
               </a:defRPr>
             </a:pPr>
             <a:r>
-              <a:t>  支援行政區下拉、學制下拉、風險等級過濾與關鍵字模糊搜尋。</a:t>
+              <a:t>僅收錄政府公開機構立案與公告處分，零收錄個人隱私資料。</a:t>
             </a:r>
           </a:p>
           <a:p>
             <a:pPr>
               <a:spcBef>
-                <a:spcPts val="1000"/>
+                <a:spcPts val="600"/>
               </a:spcBef>
-              <a:defRPr sz="1300" b="1">
-                <a:solidFill>
-                  <a:srgbClr val="2563EB"/>
-                </a:solidFill>
-              </a:defRPr>
-            </a:pPr>
-            <a:r>
-              <a:t>• 一鍵過濾「高風險警示名單」</a:t>
-            </a:r>
-          </a:p>
-          <a:p>
-            <a:pPr>
-              <a:defRPr sz="1200">
+              <a:defRPr sz="1200" b="1">
+                <a:solidFill>
+                  <a:srgbClr val="0F172A"/>
+                </a:solidFill>
+              </a:defRPr>
+            </a:pPr>
+            <a:r>
+              <a:t>✅ 3. 資料庫關閉公網存取 (Private DB)</a:t>
+            </a:r>
+          </a:p>
+          <a:p>
+            <a:pPr>
+              <a:defRPr sz="1050">
                 <a:solidFill>
                   <a:srgbClr val="64748B"/>
                 </a:solidFill>
               </a:defRPr>
             </a:pPr>
             <a:r>
-              <a:t>  即時篩出 28 所問題學校與幼兒園，快速供教育局做決策。</a:t>
+              <a:t>Aurora RDS 部署於 VPC 私有子網，Security Group 嚴禁公網直連。</a:t>
             </a:r>
           </a:p>
           <a:p>
             <a:pPr>
               <a:spcBef>
-                <a:spcPts val="1000"/>
+                <a:spcPts val="600"/>
               </a:spcBef>
-              <a:defRPr sz="1300" b="1">
-                <a:solidFill>
-                  <a:srgbClr val="2563EB"/>
-                </a:solidFill>
-              </a:defRPr>
-            </a:pPr>
-            <a:r>
-              <a:t>• 右側展開深度稽查抽屜 (AuditDrawer)</a:t>
-            </a:r>
-          </a:p>
-          <a:p>
-            <a:pPr>
-              <a:defRPr sz="1200">
+              <a:defRPr sz="1200" b="1">
+                <a:solidFill>
+                  <a:srgbClr val="0F172A"/>
+                </a:solidFill>
+              </a:defRPr>
+            </a:pPr>
+            <a:r>
+              <a:t>✅ 4. Amazon Bedrock 嚴格限流 (RPS &lt;= 1)</a:t>
+            </a:r>
+          </a:p>
+          <a:p>
+            <a:pPr>
+              <a:defRPr sz="1050">
                 <a:solidFill>
                   <a:srgbClr val="64748B"/>
                 </a:solidFill>
               </a:defRPr>
             </a:pPr>
             <a:r>
-              <a:t>  點擊任一學校即可展開查看完整處分字號、裁罰歷程、現場檢核清單。</a:t>
+              <a:t>內建令牌桶 (Token Bucket) 節流演算法，嚴格控制每秒 1 次以下。</a:t>
             </a:r>
           </a:p>
           <a:p>
             <a:pPr>
               <a:spcBef>
-                <a:spcPts val="1000"/>
+                <a:spcPts val="600"/>
               </a:spcBef>
-              <a:defRPr sz="1300" b="1">
-                <a:solidFill>
-                  <a:srgbClr val="2563EB"/>
-                </a:solidFill>
-              </a:defRPr>
-            </a:pPr>
-            <a:r>
-              <a:t>• 整合班佛採購分析與家長真實評論</a:t>
-            </a:r>
-          </a:p>
-          <a:p>
-            <a:pPr>
-              <a:defRPr sz="1200">
+              <a:defRPr sz="1200" b="1">
+                <a:solidFill>
+                  <a:srgbClr val="0F172A"/>
+                </a:solidFill>
+              </a:defRPr>
+            </a:pPr>
+            <a:r>
+              <a:t>✅ 5. 部署於指定主要區域 (Region)</a:t>
+            </a:r>
+          </a:p>
+          <a:p>
+            <a:pPr>
+              <a:defRPr sz="1050">
                 <a:solidFill>
                   <a:srgbClr val="64748B"/>
                 </a:solidFill>
               </a:defRPr>
             </a:pPr>
             <a:r>
-              <a:t>  首創將公務採購合約檢定結果與 Google 評論情感圖表直接視覺化。</a:t>
+              <a:t>全架構統一規劃部署於 AWS us-west-2 (Oregon) 區域。</a:t>
             </a:r>
           </a:p>
         </p:txBody>
@@ -6152,7 +6358,7 @@
         <p:spPr>
           <a:xfrm>
             <a:off x="731520" y="365760"/>
-            <a:ext cx="10698480" cy="365760"/>
+            <a:ext cx="10698480" cy="320040"/>
           </a:xfrm>
           <a:prstGeom prst="rect">
             <a:avLst/>
@@ -6173,7 +6379,7 @@
               </a:defRPr>
             </a:pPr>
             <a:r>
-              <a:t>AWS 黑客松競賽提案 ｜ 教育局命題：教保機構風險監測</a:t>
+              <a:t>AWS 黑客松競賽提案 ｜ 項目四 ｜ 解決方案使用介面</a:t>
             </a:r>
           </a:p>
         </p:txBody>
@@ -6187,7 +6393,7 @@
         <p:spPr>
           <a:xfrm>
             <a:off x="731520" y="640080"/>
-            <a:ext cx="10698480" cy="640080"/>
+            <a:ext cx="10698480" cy="594360"/>
           </a:xfrm>
           <a:prstGeom prst="rect">
             <a:avLst/>
@@ -6201,14 +6407,14 @@
           <a:lstStyle/>
           <a:p>
             <a:pPr>
-              <a:defRPr sz="2400" b="1">
+              <a:defRPr sz="2300" b="1">
                 <a:solidFill>
                   <a:srgbClr val="0F172A"/>
                 </a:solidFill>
               </a:defRPr>
             </a:pPr>
             <a:r>
-              <a:t>六、教育局日常操作流程與雙校對比 (Operation Flow)</a:t>
+              <a:t>項目四、使用介面及操作流程：GIS 熱點圖台與名冊</a:t>
             </a:r>
           </a:p>
         </p:txBody>
@@ -6281,122 +6487,122 @@
           <a:lstStyle/>
           <a:p>
             <a:pPr>
-              <a:defRPr sz="1800" b="1">
+              <a:defRPr sz="1700" b="1">
                 <a:solidFill>
                   <a:srgbClr val="2563EB"/>
                 </a:solidFill>
               </a:defRPr>
             </a:pPr>
             <a:r>
-              <a:t>🔄 教育局風險監測四步作業流程</a:t>
+              <a:t>🗺️ 新北 GIS 地理資訊熱點地圖</a:t>
             </a:r>
           </a:p>
           <a:p>
             <a:pPr>
               <a:spcBef>
-                <a:spcPts val="1000"/>
+                <a:spcPts val="800"/>
               </a:spcBef>
-              <a:defRPr sz="1400" b="1">
+              <a:defRPr sz="1200" b="1">
                 <a:solidFill>
                   <a:srgbClr val="0F172A"/>
                 </a:solidFill>
               </a:defRPr>
             </a:pPr>
             <a:r>
-              <a:t>Step 1. 全市儀表板宏觀盤點</a:t>
-            </a:r>
-          </a:p>
-          <a:p>
-            <a:pPr>
-              <a:defRPr sz="1200">
+              <a:t>• 新北全境 29 行政區快選膠囊</a:t>
+            </a:r>
+          </a:p>
+          <a:p>
+            <a:pPr>
+              <a:defRPr sz="1100">
                 <a:solidFill>
                   <a:srgbClr val="64748B"/>
                 </a:solidFill>
               </a:defRPr>
             </a:pPr>
             <a:r>
-              <a:t>  局端官員檢視 468 所學校風險總覽、高風險數量與累積處分統計。</a:t>
+              <a:t>  支援板橋、新莊、中和、永和、淡水、林口等 29 區一鍵縮放聚焦。</a:t>
             </a:r>
           </a:p>
           <a:p>
             <a:pPr>
               <a:spcBef>
-                <a:spcPts val="1000"/>
+                <a:spcPts val="800"/>
               </a:spcBef>
-              <a:defRPr sz="1400" b="1">
+              <a:defRPr sz="1200" b="1">
                 <a:solidFill>
                   <a:srgbClr val="0F172A"/>
                 </a:solidFill>
               </a:defRPr>
             </a:pPr>
             <a:r>
-              <a:t>Step 2. 鎖定高風險異常對象</a:t>
-            </a:r>
-          </a:p>
-          <a:p>
-            <a:pPr>
-              <a:defRPr sz="1200">
+              <a:t>• 四大全學制維度自由切換</a:t>
+            </a:r>
+          </a:p>
+          <a:p>
+            <a:pPr>
+              <a:defRPr sz="1100">
                 <a:solidFill>
                   <a:srgbClr val="64748B"/>
                 </a:solidFill>
               </a:defRPr>
             </a:pPr>
             <a:r>
-              <a:t>  篩選出紅標 28 所對象，檢視其違規類型（如超收 28 人、採購假帳）。</a:t>
+              <a:t>  即時切換高中職 (48 所)、國中 (63 所)、國小 (164 所)、幼兒園 (193 所)。</a:t>
             </a:r>
           </a:p>
           <a:p>
             <a:pPr>
               <a:spcBef>
-                <a:spcPts val="1000"/>
+                <a:spcPts val="800"/>
               </a:spcBef>
-              <a:defRPr sz="1400" b="1">
+              <a:defRPr sz="1200" b="1">
                 <a:solidFill>
                   <a:srgbClr val="0F172A"/>
                 </a:solidFill>
               </a:defRPr>
             </a:pPr>
             <a:r>
-              <a:t>Step 3. 雙校雷達指標差異分析</a:t>
-            </a:r>
-          </a:p>
-          <a:p>
-            <a:pPr>
-              <a:defRPr sz="1200">
+              <a:t>• 風險等級色彩即時分流</a:t>
+            </a:r>
+          </a:p>
+          <a:p>
+            <a:pPr>
+              <a:defRPr sz="1100">
                 <a:solidFill>
                   <a:srgbClr val="64748B"/>
                 </a:solidFill>
               </a:defRPr>
             </a:pPr>
             <a:r>
-              <a:t>  挑選同行政區兩所機構進行五維雷達對比，找出管理弱項。</a:t>
+              <a:t>  紅標（高風險）、黃標（中風險）、綠標（合格優良）清晰標記。</a:t>
             </a:r>
           </a:p>
           <a:p>
             <a:pPr>
               <a:spcBef>
-                <a:spcPts val="1000"/>
+                <a:spcPts val="800"/>
               </a:spcBef>
-              <a:defRPr sz="1400" b="1">
+              <a:defRPr sz="1200" b="1">
                 <a:solidFill>
                   <a:srgbClr val="0F172A"/>
                 </a:solidFill>
               </a:defRPr>
             </a:pPr>
             <a:r>
-              <a:t>Step 4. 自動生成現場稽查工單</a:t>
-            </a:r>
-          </a:p>
-          <a:p>
-            <a:pPr>
-              <a:defRPr sz="1200">
+              <a:t>• 點擊彈出機構全維體檢卡</a:t>
+            </a:r>
+          </a:p>
+          <a:p>
+            <a:pPr>
+              <a:defRPr sz="1100">
                 <a:solidFill>
                   <a:srgbClr val="64748B"/>
                 </a:solidFill>
               </a:defRPr>
             </a:pPr>
             <a:r>
-              <a:t>  由 AI 生成突擊稽查重點，派遣公安食安聯合督導小組出勤。</a:t>
+              <a:t>  即刻查看綜合風險分數、核定收托容量、食安合格狀態與聯絡電話。</a:t>
             </a:r>
           </a:p>
         </p:txBody>
@@ -6469,95 +6675,122 @@
           <a:lstStyle/>
           <a:p>
             <a:pPr>
-              <a:defRPr sz="1800" b="1">
-                <a:solidFill>
-                  <a:srgbClr val="0F172A"/>
-                </a:solidFill>
-              </a:defRPr>
-            </a:pPr>
-            <a:r>
-              <a:t>⚖️ 雙校五維雷達深度對比模組</a:t>
+              <a:defRPr sz="1700" b="1">
+                <a:solidFill>
+                  <a:srgbClr val="8B5CF6"/>
+                </a:solidFill>
+              </a:defRPr>
+            </a:pPr>
+            <a:r>
+              <a:t>📋 機構治理名冊與 5D 抽屜詳情 (AuditDrawer)</a:t>
             </a:r>
           </a:p>
           <a:p>
             <a:pPr>
               <a:spcBef>
-                <a:spcPts val="1200"/>
+                <a:spcPts val="800"/>
               </a:spcBef>
-              <a:defRPr sz="1400" b="1">
+              <a:defRPr sz="1200" b="1">
                 <a:solidFill>
                   <a:srgbClr val="2563EB"/>
                 </a:solidFill>
               </a:defRPr>
             </a:pPr>
             <a:r>
-              <a:t>✓ 任意跨學制／同區橫向評估</a:t>
-            </a:r>
-          </a:p>
-          <a:p>
-            <a:pPr>
-              <a:defRPr sz="1200">
+              <a:t>• 全方位多維複合篩選列</a:t>
+            </a:r>
+          </a:p>
+          <a:p>
+            <a:pPr>
+              <a:defRPr sz="1100">
                 <a:solidFill>
                   <a:srgbClr val="64748B"/>
                 </a:solidFill>
               </a:defRPr>
             </a:pPr>
             <a:r>
-              <a:t>  支援新北任意兩所學校比對，例如「板橋高中 vs 新莊高中」或「海山國小 vs 秀朗國小」。</a:t>
+              <a:t>  支援行政區下拉、學制下拉、風險等級過濾與關鍵字模糊搜尋。</a:t>
             </a:r>
           </a:p>
           <a:p>
             <a:pPr>
               <a:spcBef>
-                <a:spcPts val="1200"/>
+                <a:spcPts val="800"/>
               </a:spcBef>
-              <a:defRPr sz="1400" b="1">
+              <a:defRPr sz="1200" b="1">
                 <a:solidFill>
                   <a:srgbClr val="2563EB"/>
                 </a:solidFill>
               </a:defRPr>
             </a:pPr>
             <a:r>
-              <a:t>✓ 5 軸雷達指標直觀重疊繪製</a:t>
-            </a:r>
-          </a:p>
-          <a:p>
-            <a:pPr>
-              <a:defRPr sz="1200">
+              <a:t>• 一鍵過濾「高風險警示名單」</a:t>
+            </a:r>
+          </a:p>
+          <a:p>
+            <a:pPr>
+              <a:defRPr sz="1100">
                 <a:solidFill>
                   <a:srgbClr val="64748B"/>
                 </a:solidFill>
               </a:defRPr>
             </a:pPr>
             <a:r>
-              <a:t>  清晰看出兩校在「法規裁罰、班佛財務、社群輿情、師資流動、公安食安」的落差面積。</a:t>
+              <a:t>  即時篩出 28 所問題學校與幼兒園，快速供教育局做決策。</a:t>
             </a:r>
           </a:p>
           <a:p>
             <a:pPr>
               <a:spcBef>
-                <a:spcPts val="1200"/>
+                <a:spcPts val="800"/>
               </a:spcBef>
-              <a:defRPr sz="1400" b="1">
+              <a:defRPr sz="1200" b="1">
                 <a:solidFill>
                   <a:srgbClr val="2563EB"/>
                 </a:solidFill>
               </a:defRPr>
             </a:pPr>
             <a:r>
-              <a:t>✓ 高風險 vs 低風險對比對照</a:t>
-            </a:r>
-          </a:p>
-          <a:p>
-            <a:pPr>
-              <a:defRPr sz="1200">
+              <a:t>• 右側展開深度稽查抽屜 (AuditDrawer)</a:t>
+            </a:r>
+          </a:p>
+          <a:p>
+            <a:pPr>
+              <a:defRPr sz="1100">
                 <a:solidFill>
                   <a:srgbClr val="64748B"/>
                 </a:solidFill>
               </a:defRPr>
             </a:pPr>
             <a:r>
-              <a:t>  紅標機構五維面積顯著擴大，幫助稽查官一眼鎖定關鍵缺失問題。</a:t>
+              <a:t>  點擊任一學校即可展開查看完整處分字號、裁罰歷程、現場檢核清單。</a:t>
+            </a:r>
+          </a:p>
+          <a:p>
+            <a:pPr>
+              <a:spcBef>
+                <a:spcPts val="800"/>
+              </a:spcBef>
+              <a:defRPr sz="1200" b="1">
+                <a:solidFill>
+                  <a:srgbClr val="2563EB"/>
+                </a:solidFill>
+              </a:defRPr>
+            </a:pPr>
+            <a:r>
+              <a:t>• 整合班佛採購分析與 Google 評價</a:t>
+            </a:r>
+          </a:p>
+          <a:p>
+            <a:pPr>
+              <a:defRPr sz="1100">
+                <a:solidFill>
+                  <a:srgbClr val="64748B"/>
+                </a:solidFill>
+              </a:defRPr>
+            </a:pPr>
+            <a:r>
+              <a:t>  首創將公務採購合約檢定結果與家長評論情感圖表直接視覺化。</a:t>
             </a:r>
           </a:p>
         </p:txBody>
@@ -6632,7 +6865,7 @@
         <p:spPr>
           <a:xfrm>
             <a:off x="731520" y="365760"/>
-            <a:ext cx="10698480" cy="365760"/>
+            <a:ext cx="10698480" cy="320040"/>
           </a:xfrm>
           <a:prstGeom prst="rect">
             <a:avLst/>
@@ -6653,7 +6886,7 @@
               </a:defRPr>
             </a:pPr>
             <a:r>
-              <a:t>AWS 黑客松競賽提案 ｜ 教育局命題：教保機構風險監測</a:t>
+              <a:t>AWS 黑客松競賽提案 ｜ 項目四 ｜ 操作流程與創新功能</a:t>
             </a:r>
           </a:p>
         </p:txBody>
@@ -6667,7 +6900,7 @@
         <p:spPr>
           <a:xfrm>
             <a:off x="731520" y="640080"/>
-            <a:ext cx="10698480" cy="640080"/>
+            <a:ext cx="10698480" cy="594360"/>
           </a:xfrm>
           <a:prstGeom prst="rect">
             <a:avLst/>
@@ -6681,14 +6914,14 @@
           <a:lstStyle/>
           <a:p>
             <a:pPr>
-              <a:defRPr sz="2400" b="1">
+              <a:defRPr sz="2300" b="1">
                 <a:solidFill>
                   <a:srgbClr val="0F172A"/>
                 </a:solidFill>
               </a:defRPr>
             </a:pPr>
             <a:r>
-              <a:t>七、AI 智慧稽查室與全民吹哨者機制 (AI &amp; Whistleblower)</a:t>
+              <a:t>項目四、使用介面及操作流程：稽查 SOP 與雙校雷達</a:t>
             </a:r>
           </a:p>
         </p:txBody>
@@ -6761,20 +6994,20 @@
           <a:lstStyle/>
           <a:p>
             <a:pPr>
-              <a:defRPr sz="1800" b="1">
+              <a:defRPr sz="1700" b="1">
                 <a:solidFill>
                   <a:srgbClr val="2563EB"/>
                 </a:solidFill>
               </a:defRPr>
             </a:pPr>
             <a:r>
-              <a:t>🤖 Amazon Bedrock 賦能 AI 智慧稽查室</a:t>
+              <a:t>🔄 教育局日常監測四步標準流程 (SOP)</a:t>
             </a:r>
           </a:p>
           <a:p>
             <a:pPr>
               <a:spcBef>
-                <a:spcPts val="1000"/>
+                <a:spcPts val="800"/>
               </a:spcBef>
               <a:defRPr sz="1300" b="1">
                 <a:solidFill>
@@ -6783,25 +7016,25 @@
               </a:defRPr>
             </a:pPr>
             <a:r>
-              <a:t>• 一鍵產出客製化突擊稽查手冊</a:t>
-            </a:r>
-          </a:p>
-          <a:p>
-            <a:pPr>
-              <a:defRPr sz="1200">
+              <a:t>Step 1. 全市儀表板宏觀盤點</a:t>
+            </a:r>
+          </a:p>
+          <a:p>
+            <a:pPr>
+              <a:defRPr sz="1100">
                 <a:solidFill>
                   <a:srgbClr val="64748B"/>
                 </a:solidFill>
               </a:defRPr>
             </a:pPr>
             <a:r>
-              <a:t>  依據該校過往違規紀錄，自動條列現場實地稽查清單（如清查現場人數、調閱特定監視器時間段）。</a:t>
+              <a:t>  局端官員檢視 468 所學校風險總覽、掌握 28 所高風險動向。</a:t>
             </a:r>
           </a:p>
           <a:p>
             <a:pPr>
               <a:spcBef>
-                <a:spcPts val="1000"/>
+                <a:spcPts val="800"/>
               </a:spcBef>
               <a:defRPr sz="1300" b="1">
                 <a:solidFill>
@@ -6810,25 +7043,25 @@
               </a:defRPr>
             </a:pPr>
             <a:r>
-              <a:t>• 法條智能援引與改善建議</a:t>
-            </a:r>
-          </a:p>
-          <a:p>
-            <a:pPr>
-              <a:defRPr sz="1200">
+              <a:t>Step 2. 鎖定高風險未爆彈</a:t>
+            </a:r>
+          </a:p>
+          <a:p>
+            <a:pPr>
+              <a:defRPr sz="1100">
                 <a:solidFill>
                   <a:srgbClr val="64748B"/>
                 </a:solidFill>
               </a:defRPr>
             </a:pPr>
             <a:r>
-              <a:t>  精準對應《幼照法》第 38/51 條或《學校衛生法》，提供主管機關執法處分建議。</a:t>
+              <a:t>  篩選出紅標機構，查看其重大違規超收或財務假帳異常。</a:t>
             </a:r>
           </a:p>
           <a:p>
             <a:pPr>
               <a:spcBef>
-                <a:spcPts val="1000"/>
+                <a:spcPts val="800"/>
               </a:spcBef>
               <a:defRPr sz="1300" b="1">
                 <a:solidFill>
@@ -6837,19 +7070,46 @@
               </a:defRPr>
             </a:pPr>
             <a:r>
-              <a:t>• Bedrock API 嚴格 1 RPS 節流</a:t>
-            </a:r>
-          </a:p>
-          <a:p>
-            <a:pPr>
-              <a:defRPr sz="1200">
+              <a:t>Step 3. 雙校雷達深度比對</a:t>
+            </a:r>
+          </a:p>
+          <a:p>
+            <a:pPr>
+              <a:defRPr sz="1100">
                 <a:solidFill>
                   <a:srgbClr val="64748B"/>
                 </a:solidFill>
               </a:defRPr>
             </a:pPr>
             <a:r>
-              <a:t>  符合黑客松規範，系統內建令牌桶演算法，有效保護雲端資源。</a:t>
+              <a:t>  挑選同區兩機構進行五維雷達對比，快速識別管理短板。</a:t>
+            </a:r>
+          </a:p>
+          <a:p>
+            <a:pPr>
+              <a:spcBef>
+                <a:spcPts val="800"/>
+              </a:spcBef>
+              <a:defRPr sz="1300" b="1">
+                <a:solidFill>
+                  <a:srgbClr val="0F172A"/>
+                </a:solidFill>
+              </a:defRPr>
+            </a:pPr>
+            <a:r>
+              <a:t>Step 4. Bedrock AI 一鍵生成稽查工單</a:t>
+            </a:r>
+          </a:p>
+          <a:p>
+            <a:pPr>
+              <a:defRPr sz="1100">
+                <a:solidFill>
+                  <a:srgbClr val="64748B"/>
+                </a:solidFill>
+              </a:defRPr>
+            </a:pPr>
+            <a:r>
+              <a:t>  自動生成實地突擊稽查手冊，立即指派督導小組出勤。</a:t>
             </a:r>
           </a:p>
         </p:txBody>
@@ -6922,95 +7182,122 @@
           <a:lstStyle/>
           <a:p>
             <a:pPr>
-              <a:defRPr sz="1800" b="1">
-                <a:solidFill>
-                  <a:srgbClr val="0F172A"/>
-                </a:solidFill>
-              </a:defRPr>
-            </a:pPr>
-            <a:r>
-              <a:t>🛡️ 全民監督：匿名吹哨者檢舉通道</a:t>
+              <a:defRPr sz="1700" b="1">
+                <a:solidFill>
+                  <a:srgbClr val="8B5CF6"/>
+                </a:solidFill>
+              </a:defRPr>
+            </a:pPr>
+            <a:r>
+              <a:t>⚖️ 雙校五維雷達對比與匿名吹哨者</a:t>
             </a:r>
           </a:p>
           <a:p>
             <a:pPr>
               <a:spcBef>
-                <a:spcPts val="1000"/>
+                <a:spcPts val="800"/>
               </a:spcBef>
-              <a:defRPr sz="1300" b="1">
+              <a:defRPr sz="1200" b="1">
                 <a:solidFill>
                   <a:srgbClr val="2563EB"/>
                 </a:solidFill>
               </a:defRPr>
             </a:pPr>
             <a:r>
-              <a:t>• SHA-256 防偽雜湊鏈上存證</a:t>
-            </a:r>
-          </a:p>
-          <a:p>
-            <a:pPr>
-              <a:defRPr sz="1200">
+              <a:t>✓ 任意跨學制／同區橫向比對</a:t>
+            </a:r>
+          </a:p>
+          <a:p>
+            <a:pPr>
+              <a:defRPr sz="1100">
                 <a:solidFill>
                   <a:srgbClr val="64748B"/>
                 </a:solidFill>
               </a:defRPr>
             </a:pPr>
             <a:r>
-              <a:t>  檢舉文件與事證自動生成唯一加密雜湊（Hash Code），防止案件遭人為吃案或竄改。</a:t>
+              <a:t>  支援新北任意兩所學校比對，如板橋高中 vs 新莊高中 或 海山國小 vs 秀朗國小。</a:t>
             </a:r>
           </a:p>
           <a:p>
             <a:pPr>
               <a:spcBef>
-                <a:spcPts val="1000"/>
+                <a:spcPts val="800"/>
               </a:spcBef>
-              <a:defRPr sz="1300" b="1">
+              <a:defRPr sz="1200" b="1">
                 <a:solidFill>
                   <a:srgbClr val="2563EB"/>
                 </a:solidFill>
               </a:defRPr>
             </a:pPr>
             <a:r>
-              <a:t>• 去識別化個人保護架構</a:t>
-            </a:r>
-          </a:p>
-          <a:p>
-            <a:pPr>
-              <a:defRPr sz="1200">
+              <a:t>✓ 5 軸雷達指標直觀重疊繪製</a:t>
+            </a:r>
+          </a:p>
+          <a:p>
+            <a:pPr>
+              <a:defRPr sz="1100">
                 <a:solidFill>
                   <a:srgbClr val="64748B"/>
                 </a:solidFill>
               </a:defRPr>
             </a:pPr>
             <a:r>
-              <a:t>  檢舉人可選擇完全匿名申報，嚴格保護內部教保員或家長隱私安全。</a:t>
+              <a:t>  清晰看出兩校在「法規裁罰、班佛財務、社群輿情、師資流動、公安食安」的落差面積。</a:t>
             </a:r>
           </a:p>
           <a:p>
             <a:pPr>
               <a:spcBef>
-                <a:spcPts val="1000"/>
+                <a:spcPts val="800"/>
               </a:spcBef>
-              <a:defRPr sz="1300" b="1">
+              <a:defRPr sz="1200" b="1">
                 <a:solidFill>
                   <a:srgbClr val="2563EB"/>
                 </a:solidFill>
               </a:defRPr>
             </a:pPr>
             <a:r>
-              <a:t>• 即時權重動態回饋</a:t>
-            </a:r>
-          </a:p>
-          <a:p>
-            <a:pPr>
-              <a:defRPr sz="1200">
+              <a:t>✓ Amazon Bedrock AI 智慧稽查手冊</a:t>
+            </a:r>
+          </a:p>
+          <a:p>
+            <a:pPr>
+              <a:defRPr sz="1100">
                 <a:solidFill>
                   <a:srgbClr val="64748B"/>
                 </a:solidFill>
               </a:defRPr>
             </a:pPr>
             <a:r>
-              <a:t>  通過查證屬實之檢舉案自動納入機構風險權重，動態刷新監測燈號。</a:t>
+              <a:t>  依據歷史裁罰自動條列現場稽查清單與《幼照法》對應法條，內建 1 RPS 限流保護。</a:t>
+            </a:r>
+          </a:p>
+          <a:p>
+            <a:pPr>
+              <a:spcBef>
+                <a:spcPts val="800"/>
+              </a:spcBef>
+              <a:defRPr sz="1200" b="1">
+                <a:solidFill>
+                  <a:srgbClr val="2563EB"/>
+                </a:solidFill>
+              </a:defRPr>
+            </a:pPr>
+            <a:r>
+              <a:t>✓ 匿名吹哨者 SHA-256 防偽存證</a:t>
+            </a:r>
+          </a:p>
+          <a:p>
+            <a:pPr>
+              <a:defRPr sz="1100">
+                <a:solidFill>
+                  <a:srgbClr val="64748B"/>
+                </a:solidFill>
+              </a:defRPr>
+            </a:pPr>
+            <a:r>
+              <a:t>  提供家長與教保員匿名檢舉通道，自動生成唯一雜湊加密存證，杜絕吃案。</a:t>
             </a:r>
           </a:p>
         </p:txBody>
@@ -7085,7 +7372,7 @@
         <p:spPr>
           <a:xfrm>
             <a:off x="731520" y="365760"/>
-            <a:ext cx="10698480" cy="365760"/>
+            <a:ext cx="10698480" cy="320040"/>
           </a:xfrm>
           <a:prstGeom prst="rect">
             <a:avLst/>
@@ -7106,7 +7393,7 @@
               </a:defRPr>
             </a:pPr>
             <a:r>
-              <a:t>AWS 黑客松競賽提案 ｜ 教育局命題：教保機構風險監測</a:t>
+              <a:t>AWS 黑客松競賽提案 ｜ 預期效益與社會價值</a:t>
             </a:r>
           </a:p>
         </p:txBody>
@@ -7120,7 +7407,7 @@
         <p:spPr>
           <a:xfrm>
             <a:off x="731520" y="640080"/>
-            <a:ext cx="10698480" cy="640080"/>
+            <a:ext cx="10698480" cy="594360"/>
           </a:xfrm>
           <a:prstGeom prst="rect">
             <a:avLst/>
@@ -7134,14 +7421,14 @@
           <a:lstStyle/>
           <a:p>
             <a:pPr>
-              <a:defRPr sz="2400" b="1">
+              <a:defRPr sz="2300" b="1">
                 <a:solidFill>
                   <a:srgbClr val="0F172A"/>
                 </a:solidFill>
               </a:defRPr>
             </a:pPr>
             <a:r>
-              <a:t>八、預期效益與社會影響力 (Expected Impact)</a:t>
+              <a:t>預期效益與社會價值 (Impact &amp; Value)</a:t>
             </a:r>
           </a:p>
         </p:txBody>
@@ -7199,8 +7486,8 @@
         </p:nvSpPr>
         <p:spPr>
           <a:xfrm>
-            <a:off x="960120" y="1874519"/>
-            <a:ext cx="2871216" cy="3931920"/>
+            <a:off x="914400" y="1874519"/>
+            <a:ext cx="2962656" cy="3931920"/>
           </a:xfrm>
           <a:prstGeom prst="rect">
             <a:avLst/>
@@ -7244,7 +7531,7 @@
               <a:spcBef>
                 <a:spcPts val="1400"/>
               </a:spcBef>
-              <a:defRPr sz="1300">
+              <a:defRPr sz="1200">
                 <a:solidFill>
                   <a:srgbClr val="64748B"/>
                 </a:solidFill>
@@ -7309,8 +7596,8 @@
         </p:nvSpPr>
         <p:spPr>
           <a:xfrm>
-            <a:off x="4636008" y="1874519"/>
-            <a:ext cx="2871216" cy="3931920"/>
+            <a:off x="4590288" y="1874519"/>
+            <a:ext cx="2962656" cy="3931920"/>
           </a:xfrm>
           <a:prstGeom prst="rect">
             <a:avLst/>
@@ -7354,7 +7641,7 @@
               <a:spcBef>
                 <a:spcPts val="1400"/>
               </a:spcBef>
-              <a:defRPr sz="1300">
+              <a:defRPr sz="1200">
                 <a:solidFill>
                   <a:srgbClr val="64748B"/>
                 </a:solidFill>
@@ -7419,8 +7706,8 @@
         </p:nvSpPr>
         <p:spPr>
           <a:xfrm>
-            <a:off x="8311896" y="1874519"/>
-            <a:ext cx="2871216" cy="3931920"/>
+            <a:off x="8266176" y="1874519"/>
+            <a:ext cx="2962656" cy="3931920"/>
           </a:xfrm>
           <a:prstGeom prst="rect">
             <a:avLst/>
@@ -7464,7 +7751,7 @@
               <a:spcBef>
                 <a:spcPts val="1400"/>
               </a:spcBef>
-              <a:defRPr sz="1300">
+              <a:defRPr sz="1200">
                 <a:solidFill>
                   <a:srgbClr val="64748B"/>
                 </a:solidFill>

</xml_diff>

<commit_message>
Upload hachathon-master files including PPTX deck, 6-minute presentation script, and speaker notes to GitHub
</commit_message>
<xml_diff>
--- a/新北市校園治理情報平台_提案簡報.pptx
+++ b/新北市校園治理情報平台_提案簡報.pptx
@@ -3148,8 +3148,8 @@
         </p:nvSpPr>
         <p:spPr>
           <a:xfrm>
-            <a:off x="1097280" y="1097280"/>
-            <a:ext cx="9997135" cy="4663440"/>
+            <a:off x="1097280" y="1005840"/>
+            <a:ext cx="9997135" cy="4846320"/>
           </a:xfrm>
           <a:prstGeom prst="roundRect">
             <a:avLst/>
@@ -3193,8 +3193,8 @@
         </p:nvSpPr>
         <p:spPr>
           <a:xfrm>
-            <a:off x="1645920" y="1645920"/>
-            <a:ext cx="8869680" cy="3474720"/>
+            <a:off x="1645920" y="1463040"/>
+            <a:ext cx="8869680" cy="3840480"/>
           </a:xfrm>
           <a:prstGeom prst="rect">
             <a:avLst/>
@@ -3215,7 +3215,7 @@
               </a:defRPr>
             </a:pPr>
             <a:r>
-              <a:t>🏆 2026 AWS 黑客松競賽提案 ｜ 命題類別：教保機構風險監測（教育局）</a:t>
+              <a:t>🏆 2026 AWS 黑客松競賽提案 ｜ 命題：教保機構風險監測（教育局）</a:t>
             </a:r>
           </a:p>
           <a:p>
@@ -3249,7 +3249,7 @@
               </a:defRPr>
             </a:pPr>
             <a:r>
-              <a:t>全台首創・以數據驅動與生成式 AI 輔助之學前幼托與 K-12 校園多維治理與風險預警系統</a:t>
+              <a:t>以數據驅動與生成式 AI 賦能之學前幼托與 K-12 校園多維治理與事前風險預警決策支援系統</a:t>
             </a:r>
           </a:p>
           <a:p>
@@ -3360,7 +3360,7 @@
               </a:defRPr>
             </a:pPr>
             <a:r>
-              <a:t>AWS 黑客松競賽提案 ｜ 總結 ｜ 成果交付</a:t>
+              <a:t>AWS 黑客松競賽提案 ｜ 教育局命題：教保機構風險監測 ｜ 總結 ｜ 成果交付</a:t>
             </a:r>
           </a:p>
         </p:txBody>
@@ -3388,7 +3388,7 @@
           <a:lstStyle/>
           <a:p>
             <a:pPr>
-              <a:defRPr sz="2300" b="1">
+              <a:defRPr sz="2200" b="1">
                 <a:solidFill>
                   <a:srgbClr val="0F172A"/>
                 </a:solidFill>
@@ -3483,14 +3483,14 @@
               <a:spcBef>
                 <a:spcPts val="600"/>
               </a:spcBef>
-              <a:defRPr sz="1200">
+              <a:defRPr sz="1200" b="1">
                 <a:solidFill>
                   <a:srgbClr val="0F172A"/>
                 </a:solidFill>
               </a:defRPr>
             </a:pPr>
             <a:r>
-              <a:t>• 【1. 解決方案說明】：完整撰寫於提案簡報與 GitHub README（5D 治理指標、班佛定律防弊、全學制覆蓋）</a:t>
+              <a:t>• 【1. 解決方案說明】：完整對齊官方 4 大痛點，提出 5D 多維治理模型與新北 468 所機構實測分級</a:t>
             </a:r>
           </a:p>
           <a:p>
@@ -3498,14 +3498,14 @@
               <a:spcBef>
                 <a:spcPts val="600"/>
               </a:spcBef>
-              <a:defRPr sz="1200">
+              <a:defRPr sz="1200" b="1">
                 <a:solidFill>
                   <a:srgbClr val="0F172A"/>
                 </a:solidFill>
               </a:defRPr>
             </a:pPr>
             <a:r>
-              <a:t>• 【2. 數據及資料運用】：整合教育部、新北市 Open Data、採購網與 Google 評價，收錄新北 468 所真實校園</a:t>
+              <a:t>• 【2. 數據及資料運用】：整合教育部、新北市 Open Data、採購網與 Google 評價，首創班佛定律假帳防弊</a:t>
             </a:r>
           </a:p>
           <a:p>
@@ -3513,7 +3513,7 @@
               <a:spcBef>
                 <a:spcPts val="600"/>
               </a:spcBef>
-              <a:defRPr sz="1200">
+              <a:defRPr sz="1200" b="1">
                 <a:solidFill>
                   <a:srgbClr val="0F172A"/>
                 </a:solidFill>
@@ -3528,7 +3528,7 @@
               <a:spcBef>
                 <a:spcPts val="600"/>
               </a:spcBef>
-              <a:defRPr sz="1200">
+              <a:defRPr sz="1200" b="1">
                 <a:solidFill>
                   <a:srgbClr val="0F172A"/>
                 </a:solidFill>
@@ -3543,7 +3543,7 @@
               <a:spcBef>
                 <a:spcPts val="600"/>
               </a:spcBef>
-              <a:defRPr sz="1200">
+              <a:defRPr sz="1200" b="1">
                 <a:solidFill>
                   <a:srgbClr val="0F172A"/>
                 </a:solidFill>
@@ -3558,7 +3558,7 @@
               <a:spcBef>
                 <a:spcPts val="600"/>
               </a:spcBef>
-              <a:defRPr sz="1200">
+              <a:defRPr sz="1200" b="1">
                 <a:solidFill>
                   <a:srgbClr val="0F172A"/>
                 </a:solidFill>
@@ -3676,7 +3676,7 @@
               </a:defRPr>
             </a:pPr>
             <a:r>
-              <a:t>AWS 黑客松競賽提案 ｜ AGENDA 簡報大綱</a:t>
+              <a:t>AWS 黑客松競賽提案 ｜ 教育局命題：教保機構風險監測 ｜ 命題背景與痛點</a:t>
             </a:r>
           </a:p>
         </p:txBody>
@@ -3704,14 +3704,14 @@
           <a:lstStyle/>
           <a:p>
             <a:pPr>
-              <a:defRPr sz="2300" b="1">
+              <a:defRPr sz="2200" b="1">
                 <a:solidFill>
                   <a:srgbClr val="0F172A"/>
                 </a:solidFill>
               </a:defRPr>
             </a:pPr>
             <a:r>
-              <a:t>提案大綱：對齊大會指定 4 大核心項目</a:t>
+              <a:t>官方想解決問題剖析 (Official Problem Statement)</a:t>
             </a:r>
           </a:p>
         </p:txBody>
@@ -3725,6 +3725,226 @@
         <p:spPr>
           <a:xfrm>
             <a:off x="731520" y="1645920"/>
+            <a:ext cx="2468880" cy="4389120"/>
+          </a:xfrm>
+          <a:prstGeom prst="roundRect">
+            <a:avLst/>
+          </a:prstGeom>
+          <a:solidFill>
+            <a:srgbClr val="FFFFFF"/>
+          </a:solidFill>
+          <a:ln w="15240">
+            <a:solidFill>
+              <a:srgbClr val="DC2626"/>
+            </a:solidFill>
+          </a:ln>
+        </p:spPr>
+        <p:style>
+          <a:lnRef idx="1">
+            <a:schemeClr val="accent1"/>
+          </a:lnRef>
+          <a:fillRef idx="3">
+            <a:schemeClr val="accent1"/>
+          </a:fillRef>
+          <a:effectRef idx="2">
+            <a:schemeClr val="accent1"/>
+          </a:effectRef>
+          <a:fontRef idx="minor">
+            <a:schemeClr val="lt1"/>
+          </a:fontRef>
+        </p:style>
+        <p:txBody>
+          <a:bodyPr rtlCol="0" anchor="ctr"/>
+          <a:lstStyle/>
+          <a:p>
+            <a:pPr algn="ctr"/>
+          </a:p>
+        </p:txBody>
+      </p:sp>
+      <p:sp>
+        <p:nvSpPr>
+          <p:cNvPr id="6" name="TextBox 5"/>
+          <p:cNvSpPr txBox="1"/>
+          <p:nvPr/>
+        </p:nvSpPr>
+        <p:spPr>
+          <a:xfrm>
+            <a:off x="868680" y="1783080"/>
+            <a:ext cx="2194560" cy="4023360"/>
+          </a:xfrm>
+          <a:prstGeom prst="rect">
+            <a:avLst/>
+          </a:prstGeom>
+          <a:noFill/>
+        </p:spPr>
+        <p:txBody>
+          <a:bodyPr wrap="square">
+            <a:spAutoFit/>
+          </a:bodyPr>
+          <a:lstStyle/>
+          <a:p>
+            <a:pPr>
+              <a:defRPr sz="1400" b="1">
+                <a:solidFill>
+                  <a:srgbClr val="DC2626"/>
+                </a:solidFill>
+              </a:defRPr>
+            </a:pPr>
+            <a:r>
+              <a:t>1. 資料分散與整合困難</a:t>
+            </a:r>
+          </a:p>
+          <a:p>
+            <a:pPr>
+              <a:spcBef>
+                <a:spcPts val="400"/>
+              </a:spcBef>
+              <a:defRPr sz="1100" b="1">
+                <a:solidFill>
+                  <a:srgbClr val="0F172A"/>
+                </a:solidFill>
+              </a:defRPr>
+            </a:pPr>
+            <a:r>
+              <a:t>公開資訊散落缺乏整合</a:t>
+            </a:r>
+          </a:p>
+          <a:p>
+            <a:pPr>
+              <a:spcBef>
+                <a:spcPts val="1000"/>
+              </a:spcBef>
+              <a:defRPr sz="1100">
+                <a:solidFill>
+                  <a:srgbClr val="64748B"/>
+                </a:solidFill>
+              </a:defRPr>
+            </a:pPr>
+            <a:r>
+              <a:t>基本資料、評鑑歷程、裁罰紀錄、收費明細及財務決算雖為公開資訊，但分散於不同系統缺乏整合分析機制，且未納入社群即時輿情，難以形成完整客觀的風險判斷基礎。</a:t>
+            </a:r>
+          </a:p>
+        </p:txBody>
+      </p:sp>
+      <p:sp>
+        <p:nvSpPr>
+          <p:cNvPr id="7" name="Rounded Rectangle 6"/>
+          <p:cNvSpPr/>
+          <p:nvPr/>
+        </p:nvSpPr>
+        <p:spPr>
+          <a:xfrm>
+            <a:off x="3483864" y="1645920"/>
+            <a:ext cx="2468880" cy="4389120"/>
+          </a:xfrm>
+          <a:prstGeom prst="roundRect">
+            <a:avLst/>
+          </a:prstGeom>
+          <a:solidFill>
+            <a:srgbClr val="FFFFFF"/>
+          </a:solidFill>
+          <a:ln w="15240">
+            <a:solidFill>
+              <a:srgbClr val="D97706"/>
+            </a:solidFill>
+          </a:ln>
+        </p:spPr>
+        <p:style>
+          <a:lnRef idx="1">
+            <a:schemeClr val="accent1"/>
+          </a:lnRef>
+          <a:fillRef idx="3">
+            <a:schemeClr val="accent1"/>
+          </a:fillRef>
+          <a:effectRef idx="2">
+            <a:schemeClr val="accent1"/>
+          </a:effectRef>
+          <a:fontRef idx="minor">
+            <a:schemeClr val="lt1"/>
+          </a:fontRef>
+        </p:style>
+        <p:txBody>
+          <a:bodyPr rtlCol="0" anchor="ctr"/>
+          <a:lstStyle/>
+          <a:p>
+            <a:pPr algn="ctr"/>
+          </a:p>
+        </p:txBody>
+      </p:sp>
+      <p:sp>
+        <p:nvSpPr>
+          <p:cNvPr id="8" name="TextBox 7"/>
+          <p:cNvSpPr txBox="1"/>
+          <p:nvPr/>
+        </p:nvSpPr>
+        <p:spPr>
+          <a:xfrm>
+            <a:off x="3621024" y="1783080"/>
+            <a:ext cx="2194560" cy="4023360"/>
+          </a:xfrm>
+          <a:prstGeom prst="rect">
+            <a:avLst/>
+          </a:prstGeom>
+          <a:noFill/>
+        </p:spPr>
+        <p:txBody>
+          <a:bodyPr wrap="square">
+            <a:spAutoFit/>
+          </a:bodyPr>
+          <a:lstStyle/>
+          <a:p>
+            <a:pPr>
+              <a:defRPr sz="1400" b="1">
+                <a:solidFill>
+                  <a:srgbClr val="D97706"/>
+                </a:solidFill>
+              </a:defRPr>
+            </a:pPr>
+            <a:r>
+              <a:t>2. 財務異常難以及早發現</a:t>
+            </a:r>
+          </a:p>
+          <a:p>
+            <a:pPr>
+              <a:spcBef>
+                <a:spcPts val="400"/>
+              </a:spcBef>
+              <a:defRPr sz="1100" b="1">
+                <a:solidFill>
+                  <a:srgbClr val="0F172A"/>
+                </a:solidFill>
+              </a:defRPr>
+            </a:pPr>
+            <a:r>
+              <a:t>決算報告未交叉勾稽</a:t>
+            </a:r>
+          </a:p>
+          <a:p>
+            <a:pPr>
+              <a:spcBef>
+                <a:spcPts val="1000"/>
+              </a:spcBef>
+              <a:defRPr sz="1100">
+                <a:solidFill>
+                  <a:srgbClr val="64748B"/>
+                </a:solidFill>
+              </a:defRPr>
+            </a:pPr>
+            <a:r>
+              <a:t>公共化幼兒園之決算或財務報告雖依法公告，但傳統模式缺乏與收費明細、核定收托規模、採購工程等資訊進行深度交叉分析，難以在第一時間自動偵測人為拆單或做假帳等財務異常。</a:t>
+            </a:r>
+          </a:p>
+        </p:txBody>
+      </p:sp>
+      <p:sp>
+        <p:nvSpPr>
+          <p:cNvPr id="9" name="Rounded Rectangle 8"/>
+          <p:cNvSpPr/>
+          <p:nvPr/>
+        </p:nvSpPr>
+        <p:spPr>
+          <a:xfrm>
+            <a:off x="6236208" y="1645920"/>
             <a:ext cx="2468880" cy="4389120"/>
           </a:xfrm>
           <a:prstGeom prst="roundRect">
@@ -3763,14 +3983,14 @@
       </p:sp>
       <p:sp>
         <p:nvSpPr>
-          <p:cNvPr id="6" name="TextBox 5"/>
+          <p:cNvPr id="10" name="TextBox 9"/>
           <p:cNvSpPr txBox="1"/>
           <p:nvPr/>
         </p:nvSpPr>
         <p:spPr>
           <a:xfrm>
-            <a:off x="868680" y="1828800"/>
-            <a:ext cx="2194560" cy="3931920"/>
+            <a:off x="6373368" y="1783080"/>
+            <a:ext cx="2194560" cy="4023360"/>
           </a:xfrm>
           <a:prstGeom prst="rect">
             <a:avLst/>
@@ -3784,29 +4004,14 @@
           <a:lstStyle/>
           <a:p>
             <a:pPr>
-              <a:defRPr sz="2800" b="1">
+              <a:defRPr sz="1400" b="1">
                 <a:solidFill>
                   <a:srgbClr val="2563EB"/>
                 </a:solidFill>
               </a:defRPr>
             </a:pPr>
             <a:r>
-              <a:t>01</a:t>
-            </a:r>
-          </a:p>
-          <a:p>
-            <a:pPr>
-              <a:spcBef>
-                <a:spcPts val="400"/>
-              </a:spcBef>
-              <a:defRPr sz="1600" b="1">
-                <a:solidFill>
-                  <a:srgbClr val="0F172A"/>
-                </a:solidFill>
-              </a:defRPr>
-            </a:pPr>
-            <a:r>
-              <a:t>解決方案說明</a:t>
+              <a:t>3. 風險辨識與預警不足</a:t>
             </a:r>
           </a:p>
           <a:p>
@@ -3816,313 +4021,27 @@
               </a:spcBef>
               <a:defRPr sz="1100" b="1">
                 <a:solidFill>
-                  <a:srgbClr val="2563EB"/>
-                </a:solidFill>
-              </a:defRPr>
-            </a:pPr>
-            <a:r>
-              <a:t>5D 模型與三級風險梯隊</a:t>
+                  <a:srgbClr val="0F172A"/>
+                </a:solidFill>
+              </a:defRPr>
+            </a:pPr>
+            <a:r>
+              <a:t>缺乏量化預警工具</a:t>
             </a:r>
           </a:p>
           <a:p>
             <a:pPr>
               <a:spcBef>
-                <a:spcPts val="1200"/>
+                <a:spcPts val="1000"/>
               </a:spcBef>
-              <a:defRPr sz="1200">
+              <a:defRPr sz="1100">
                 <a:solidFill>
                   <a:srgbClr val="64748B"/>
                 </a:solidFill>
               </a:defRPr>
             </a:pPr>
             <a:r>
-              <a:t>• 現行稽查三大痛點剖析</a:t>
-            </a:r>
-            <a:br/>
-            <a:r>
-              <a:t>• 獨創 5D 校園多維治理指標</a:t>
-            </a:r>
-            <a:br/>
-            <a:r>
-              <a:t>• 新北 468 所機構實測分級</a:t>
-            </a:r>
-            <a:br/>
-            <a:r>
-              <a:t>• 事前預警機制與稽查賦能</a:t>
-            </a:r>
-          </a:p>
-        </p:txBody>
-      </p:sp>
-      <p:sp>
-        <p:nvSpPr>
-          <p:cNvPr id="7" name="Rounded Rectangle 6"/>
-          <p:cNvSpPr/>
-          <p:nvPr/>
-        </p:nvSpPr>
-        <p:spPr>
-          <a:xfrm>
-            <a:off x="3483864" y="1645920"/>
-            <a:ext cx="2468880" cy="4389120"/>
-          </a:xfrm>
-          <a:prstGeom prst="roundRect">
-            <a:avLst/>
-          </a:prstGeom>
-          <a:solidFill>
-            <a:srgbClr val="FFFFFF"/>
-          </a:solidFill>
-          <a:ln w="15240">
-            <a:solidFill>
-              <a:srgbClr val="10B981"/>
-            </a:solidFill>
-          </a:ln>
-        </p:spPr>
-        <p:style>
-          <a:lnRef idx="1">
-            <a:schemeClr val="accent1"/>
-          </a:lnRef>
-          <a:fillRef idx="3">
-            <a:schemeClr val="accent1"/>
-          </a:fillRef>
-          <a:effectRef idx="2">
-            <a:schemeClr val="accent1"/>
-          </a:effectRef>
-          <a:fontRef idx="minor">
-            <a:schemeClr val="lt1"/>
-          </a:fontRef>
-        </p:style>
-        <p:txBody>
-          <a:bodyPr rtlCol="0" anchor="ctr"/>
-          <a:lstStyle/>
-          <a:p>
-            <a:pPr algn="ctr"/>
-          </a:p>
-        </p:txBody>
-      </p:sp>
-      <p:sp>
-        <p:nvSpPr>
-          <p:cNvPr id="8" name="TextBox 7"/>
-          <p:cNvSpPr txBox="1"/>
-          <p:nvPr/>
-        </p:nvSpPr>
-        <p:spPr>
-          <a:xfrm>
-            <a:off x="3621024" y="1828800"/>
-            <a:ext cx="2194560" cy="3931920"/>
-          </a:xfrm>
-          <a:prstGeom prst="rect">
-            <a:avLst/>
-          </a:prstGeom>
-          <a:noFill/>
-        </p:spPr>
-        <p:txBody>
-          <a:bodyPr wrap="square">
-            <a:spAutoFit/>
-          </a:bodyPr>
-          <a:lstStyle/>
-          <a:p>
-            <a:pPr>
-              <a:defRPr sz="2800" b="1">
-                <a:solidFill>
-                  <a:srgbClr val="10B981"/>
-                </a:solidFill>
-              </a:defRPr>
-            </a:pPr>
-            <a:r>
-              <a:t>02</a:t>
-            </a:r>
-          </a:p>
-          <a:p>
-            <a:pPr>
-              <a:spcBef>
-                <a:spcPts val="400"/>
-              </a:spcBef>
-              <a:defRPr sz="1600" b="1">
-                <a:solidFill>
-                  <a:srgbClr val="0F172A"/>
-                </a:solidFill>
-              </a:defRPr>
-            </a:pPr>
-            <a:r>
-              <a:t>數據及資料運用</a:t>
-            </a:r>
-          </a:p>
-          <a:p>
-            <a:pPr>
-              <a:spcBef>
-                <a:spcPts val="400"/>
-              </a:spcBef>
-              <a:defRPr sz="1100" b="1">
-                <a:solidFill>
-                  <a:srgbClr val="10B981"/>
-                </a:solidFill>
-              </a:defRPr>
-            </a:pPr>
-            <a:r>
-              <a:t>4 大官方數據源與防弊模型</a:t>
-            </a:r>
-          </a:p>
-          <a:p>
-            <a:pPr>
-              <a:spcBef>
-                <a:spcPts val="1200"/>
-              </a:spcBef>
-              <a:defRPr sz="1200">
-                <a:solidFill>
-                  <a:srgbClr val="64748B"/>
-                </a:solidFill>
-              </a:defRPr>
-            </a:pPr>
-            <a:r>
-              <a:t>• 教育部、新北OpenData、採購網</a:t>
-            </a:r>
-            <a:br/>
-            <a:r>
-              <a:t>• 班佛定律 (Benford's Law) 假帳檢定</a:t>
-            </a:r>
-            <a:br/>
-            <a:r>
-              <a:t>• Google 評論 NLP 情感探勘</a:t>
-            </a:r>
-            <a:br/>
-            <a:r>
-              <a:t>• 多因子動態風險量化演算法</a:t>
-            </a:r>
-          </a:p>
-        </p:txBody>
-      </p:sp>
-      <p:sp>
-        <p:nvSpPr>
-          <p:cNvPr id="9" name="Rounded Rectangle 8"/>
-          <p:cNvSpPr/>
-          <p:nvPr/>
-        </p:nvSpPr>
-        <p:spPr>
-          <a:xfrm>
-            <a:off x="6236208" y="1645920"/>
-            <a:ext cx="2468880" cy="4389120"/>
-          </a:xfrm>
-          <a:prstGeom prst="roundRect">
-            <a:avLst/>
-          </a:prstGeom>
-          <a:solidFill>
-            <a:srgbClr val="FFFFFF"/>
-          </a:solidFill>
-          <a:ln w="15240">
-            <a:solidFill>
-              <a:srgbClr val="D97706"/>
-            </a:solidFill>
-          </a:ln>
-        </p:spPr>
-        <p:style>
-          <a:lnRef idx="1">
-            <a:schemeClr val="accent1"/>
-          </a:lnRef>
-          <a:fillRef idx="3">
-            <a:schemeClr val="accent1"/>
-          </a:fillRef>
-          <a:effectRef idx="2">
-            <a:schemeClr val="accent1"/>
-          </a:effectRef>
-          <a:fontRef idx="minor">
-            <a:schemeClr val="lt1"/>
-          </a:fontRef>
-        </p:style>
-        <p:txBody>
-          <a:bodyPr rtlCol="0" anchor="ctr"/>
-          <a:lstStyle/>
-          <a:p>
-            <a:pPr algn="ctr"/>
-          </a:p>
-        </p:txBody>
-      </p:sp>
-      <p:sp>
-        <p:nvSpPr>
-          <p:cNvPr id="10" name="TextBox 9"/>
-          <p:cNvSpPr txBox="1"/>
-          <p:nvPr/>
-        </p:nvSpPr>
-        <p:spPr>
-          <a:xfrm>
-            <a:off x="6373368" y="1828800"/>
-            <a:ext cx="2194560" cy="3931920"/>
-          </a:xfrm>
-          <a:prstGeom prst="rect">
-            <a:avLst/>
-          </a:prstGeom>
-          <a:noFill/>
-        </p:spPr>
-        <p:txBody>
-          <a:bodyPr wrap="square">
-            <a:spAutoFit/>
-          </a:bodyPr>
-          <a:lstStyle/>
-          <a:p>
-            <a:pPr>
-              <a:defRPr sz="2800" b="1">
-                <a:solidFill>
-                  <a:srgbClr val="D97706"/>
-                </a:solidFill>
-              </a:defRPr>
-            </a:pPr>
-            <a:r>
-              <a:t>03</a:t>
-            </a:r>
-          </a:p>
-          <a:p>
-            <a:pPr>
-              <a:spcBef>
-                <a:spcPts val="400"/>
-              </a:spcBef>
-              <a:defRPr sz="1600" b="1">
-                <a:solidFill>
-                  <a:srgbClr val="0F172A"/>
-                </a:solidFill>
-              </a:defRPr>
-            </a:pPr>
-            <a:r>
-              <a:t>AWS 雲端技術架構</a:t>
-            </a:r>
-          </a:p>
-          <a:p>
-            <a:pPr>
-              <a:spcBef>
-                <a:spcPts val="400"/>
-              </a:spcBef>
-              <a:defRPr sz="1100" b="1">
-                <a:solidFill>
-                  <a:srgbClr val="D97706"/>
-                </a:solidFill>
-              </a:defRPr>
-            </a:pPr>
-            <a:r>
-              <a:t>含架構圖與大會安全檢核</a:t>
-            </a:r>
-          </a:p>
-          <a:p>
-            <a:pPr>
-              <a:spcBef>
-                <a:spcPts val="1200"/>
-              </a:spcBef>
-              <a:defRPr sz="1200">
-                <a:solidFill>
-                  <a:srgbClr val="64748B"/>
-                </a:solidFill>
-              </a:defRPr>
-            </a:pPr>
-            <a:r>
-              <a:t>• 全端無伺服器與微服務拓撲圖</a:t>
-            </a:r>
-            <a:br/>
-            <a:r>
-              <a:t>• S3 Block Public Access + OAC</a:t>
-            </a:r>
-            <a:br/>
-            <a:r>
-              <a:t>• VPC 私有子網 Aurora RDS</a:t>
-            </a:r>
-            <a:br/>
-            <a:r>
-              <a:t>• Bedrock RPS &lt;= 1 令牌桶限流</a:t>
+              <a:t>主管機關缺乏標準化、可量化的風險動態評估工具，面對新北逾 1,500 所公私立學校與幼托，無法迅速且客觀地從大量機構中自動篩選出需優先關注的高風險未爆彈。</a:t>
             </a:r>
           </a:p>
         </p:txBody>
@@ -4180,8 +4099,8 @@
         </p:nvSpPr>
         <p:spPr>
           <a:xfrm>
-            <a:off x="9125712" y="1828800"/>
-            <a:ext cx="2194560" cy="3931920"/>
+            <a:off x="9125712" y="1783080"/>
+            <a:ext cx="2194560" cy="4023360"/>
           </a:xfrm>
           <a:prstGeom prst="rect">
             <a:avLst/>
@@ -4195,29 +4114,14 @@
           <a:lstStyle/>
           <a:p>
             <a:pPr>
-              <a:defRPr sz="2800" b="1">
+              <a:defRPr sz="1400" b="1">
                 <a:solidFill>
                   <a:srgbClr val="8B5CF6"/>
                 </a:solidFill>
               </a:defRPr>
             </a:pPr>
             <a:r>
-              <a:t>04</a:t>
-            </a:r>
-          </a:p>
-          <a:p>
-            <a:pPr>
-              <a:spcBef>
-                <a:spcPts val="400"/>
-              </a:spcBef>
-              <a:defRPr sz="1600" b="1">
-                <a:solidFill>
-                  <a:srgbClr val="0F172A"/>
-                </a:solidFill>
-              </a:defRPr>
-            </a:pPr>
-            <a:r>
-              <a:t>使用介面及操作流程</a:t>
+              <a:t>4. 人力負擔重與決策支援不足</a:t>
             </a:r>
           </a:p>
           <a:p>
@@ -4227,39 +4131,27 @@
               </a:spcBef>
               <a:defRPr sz="1100" b="1">
                 <a:solidFill>
-                  <a:srgbClr val="8B5CF6"/>
-                </a:solidFill>
-              </a:defRPr>
-            </a:pPr>
-            <a:r>
-              <a:t>GIS、雷達對比與 AI 稽查</a:t>
+                  <a:srgbClr val="0F172A"/>
+                </a:solidFill>
+              </a:defRPr>
+            </a:pPr>
+            <a:r>
+              <a:t>仰賴人工耗時費力</a:t>
             </a:r>
           </a:p>
           <a:p>
             <a:pPr>
               <a:spcBef>
-                <a:spcPts val="1200"/>
+                <a:spcPts val="1000"/>
               </a:spcBef>
-              <a:defRPr sz="1200">
+              <a:defRPr sz="1100">
                 <a:solidFill>
                   <a:srgbClr val="64748B"/>
                 </a:solidFill>
               </a:defRPr>
             </a:pPr>
             <a:r>
-              <a:t>• 新北 29 區 GIS 地理熱點圖台</a:t>
-            </a:r>
-            <a:br/>
-            <a:r>
-              <a:t>• 機構名冊與 5D 深度稽查抽屜</a:t>
-            </a:r>
-            <a:br/>
-            <a:r>
-              <a:t>• 雙校五維雷達對比分析</a:t>
-            </a:r>
-            <a:br/>
-            <a:r>
-              <a:t>• 教育局 4 步現場稽查 SOP</a:t>
+              <a:t>機構數量龐大，專任稽查人力極度有限。傳統仰賴人工肉眼篩選與經驗判斷耗時費力，且缺乏客觀數據與 AI 決策輔助，難以支援最優化的公務資源配置策略。</a:t>
             </a:r>
           </a:p>
         </p:txBody>
@@ -4355,7 +4247,7 @@
               </a:defRPr>
             </a:pPr>
             <a:r>
-              <a:t>AWS 黑客松競賽提案 ｜ 項目一 ｜ 解決方案說明</a:t>
+              <a:t>AWS 黑客松競賽提案 ｜ 教育局命題：教保機構風險監測 ｜ 壹、解決方案說明</a:t>
             </a:r>
           </a:p>
         </p:txBody>
@@ -4383,14 +4275,14 @@
           <a:lstStyle/>
           <a:p>
             <a:pPr>
-              <a:defRPr sz="2300" b="1">
+              <a:defRPr sz="2200" b="1">
                 <a:solidFill>
                   <a:srgbClr val="0F172A"/>
                 </a:solidFill>
               </a:defRPr>
             </a:pPr>
             <a:r>
-              <a:t>項目一、解決方案說明：痛點與 5D 多維治理模型</a:t>
+              <a:t>解決方案說明：獨創「5D 校園治理全景指標模型」</a:t>
             </a:r>
           </a:p>
         </p:txBody>
@@ -4448,7 +4340,7 @@
         </p:nvSpPr>
         <p:spPr>
           <a:xfrm>
-            <a:off x="960120" y="1874519"/>
+            <a:off x="960120" y="1828800"/>
             <a:ext cx="4754880" cy="3931920"/>
           </a:xfrm>
           <a:prstGeom prst="rect">
@@ -4465,27 +4357,27 @@
             <a:pPr>
               <a:defRPr sz="1700" b="1">
                 <a:solidFill>
-                  <a:srgbClr val="DC2626"/>
-                </a:solidFill>
-              </a:defRPr>
-            </a:pPr>
-            <a:r>
-              <a:t>🚨 現行校園與教保稽查三大瓶頸</a:t>
+                  <a:srgbClr val="2563EB"/>
+                </a:solidFill>
+              </a:defRPr>
+            </a:pPr>
+            <a:r>
+              <a:t>🎯 5D 指標如何全方位破解官方 4 大難題</a:t>
             </a:r>
           </a:p>
           <a:p>
             <a:pPr>
               <a:spcBef>
-                <a:spcPts val="800"/>
+                <a:spcPts val="600"/>
               </a:spcBef>
-              <a:defRPr sz="1300" b="1">
+              <a:defRPr sz="1200" b="1">
                 <a:solidFill>
                   <a:srgbClr val="0F172A"/>
                 </a:solidFill>
               </a:defRPr>
             </a:pPr>
             <a:r>
-              <a:t>• 1. 事後被動滅火：</a:t>
+              <a:t>✓ 1. 裁罰法規違規維度 (35%)</a:t>
             </a:r>
           </a:p>
           <a:p>
@@ -4497,22 +4389,22 @@
               </a:defRPr>
             </a:pPr>
             <a:r>
-              <a:t>  傳統稽查高度仰賴家長事後申訴或重大案件爆發（如超收28人、未核備教保員、不當管教），孩童身心已受實質傷害，教育局疲於滅火。</a:t>
+              <a:t>   破解資料分散：整合跨年度裁罰字號、超收幼童人數、黑牌無證教保員記點。</a:t>
             </a:r>
           </a:p>
           <a:p>
             <a:pPr>
               <a:spcBef>
-                <a:spcPts val="800"/>
+                <a:spcPts val="600"/>
               </a:spcBef>
-              <a:defRPr sz="1300" b="1">
+              <a:defRPr sz="1200" b="1">
                 <a:solidFill>
                   <a:srgbClr val="0F172A"/>
                 </a:solidFill>
               </a:defRPr>
             </a:pPr>
             <a:r>
-              <a:t>• 2. 局處資料孤島：</a:t>
+              <a:t>✓ 2. 班佛採購財務維度 (20%)</a:t>
             </a:r>
           </a:p>
           <a:p>
@@ -4524,22 +4416,22 @@
               </a:defRPr>
             </a:pPr>
             <a:r>
-              <a:t>  裁罰歷程、食材登錄、採購標案、公安消防與 Google 評論散落各系統，未打通橫向勾稽，無法綜合研判隱性未爆彈。</a:t>
+              <a:t>   破解財務異常難發現：首創導入 Benford's Law 首位數字卡方檢定，偵測拆單假帳。</a:t>
             </a:r>
           </a:p>
           <a:p>
             <a:pPr>
               <a:spcBef>
-                <a:spcPts val="800"/>
+                <a:spcPts val="600"/>
               </a:spcBef>
-              <a:defRPr sz="1300" b="1">
+              <a:defRPr sz="1200" b="1">
                 <a:solidFill>
                   <a:srgbClr val="0F172A"/>
                 </a:solidFill>
               </a:defRPr>
             </a:pPr>
             <a:r>
-              <a:t>• 3. 稽查人力難以普查：</a:t>
+              <a:t>✓ 3. 社群負面輿情維度 (20%)</a:t>
             </a:r>
           </a:p>
           <a:p>
@@ -4551,7 +4443,61 @@
               </a:defRPr>
             </a:pPr>
             <a:r>
-              <a:t>  新北 29 區逾 1,500 所學校與幼托，專任稽查員難以地毯式普查，急需 AI 智慧風險分流，精準打擊高風險機構。</a:t>
+              <a:t>   破解未納入即時輿情：採集 Google Places 即時家長真實評論，NLP 情感探勘。</a:t>
+            </a:r>
+          </a:p>
+          <a:p>
+            <a:pPr>
+              <a:spcBef>
+                <a:spcPts val="600"/>
+              </a:spcBef>
+              <a:defRPr sz="1200" b="1">
+                <a:solidFill>
+                  <a:srgbClr val="0F172A"/>
+                </a:solidFill>
+              </a:defRPr>
+            </a:pPr>
+            <a:r>
+              <a:t>✓ 4. 師資異動流動維度 (15%)</a:t>
+            </a:r>
+          </a:p>
+          <a:p>
+            <a:pPr>
+              <a:defRPr sz="1100">
+                <a:solidFill>
+                  <a:srgbClr val="64748B"/>
+                </a:solidFill>
+              </a:defRPr>
+            </a:pPr>
+            <a:r>
+              <a:t>   破解風險辨識不足：追蹤核心師資頻繁離退、投保在職核備名冊合規性。</a:t>
+            </a:r>
+          </a:p>
+          <a:p>
+            <a:pPr>
+              <a:spcBef>
+                <a:spcPts val="600"/>
+              </a:spcBef>
+              <a:defRPr sz="1200" b="1">
+                <a:solidFill>
+                  <a:srgbClr val="0F172A"/>
+                </a:solidFill>
+              </a:defRPr>
+            </a:pPr>
+            <a:r>
+              <a:t>✓ 5. 環境公安食安維度 (10%)</a:t>
+            </a:r>
+          </a:p>
+          <a:p>
+            <a:pPr>
+              <a:defRPr sz="1100">
+                <a:solidFill>
+                  <a:srgbClr val="64748B"/>
+                </a:solidFill>
+              </a:defRPr>
+            </a:pPr>
+            <a:r>
+              <a:t>   全面防護：午餐食材溯源 48h 留樣檢驗履歷與校舍防墜安全合格證書。</a:t>
             </a:r>
           </a:p>
         </p:txBody>
@@ -4609,7 +4555,7 @@
         </p:nvSpPr>
         <p:spPr>
           <a:xfrm>
-            <a:off x="6446520" y="1874519"/>
+            <a:off x="6446520" y="1828800"/>
             <a:ext cx="4754880" cy="3931920"/>
           </a:xfrm>
           <a:prstGeom prst="rect">
@@ -4626,27 +4572,54 @@
             <a:pPr>
               <a:defRPr sz="1700" b="1">
                 <a:solidFill>
+                  <a:srgbClr val="10B981"/>
+                </a:solidFill>
+              </a:defRPr>
+            </a:pPr>
+            <a:r>
+              <a:t>⚡ 方案效益：從「被動滅火」升級「事前預警」</a:t>
+            </a:r>
+          </a:p>
+          <a:p>
+            <a:pPr>
+              <a:spcBef>
+                <a:spcPts val="800"/>
+              </a:spcBef>
+              <a:defRPr sz="1300" b="1">
+                <a:solidFill>
                   <a:srgbClr val="2563EB"/>
                 </a:solidFill>
               </a:defRPr>
             </a:pPr>
             <a:r>
-              <a:t>🎯 獨創「5D 校園多維治理指標模型」</a:t>
+              <a:t>• 破除資料孤島：</a:t>
+            </a:r>
+          </a:p>
+          <a:p>
+            <a:pPr>
+              <a:defRPr sz="1100">
+                <a:solidFill>
+                  <a:srgbClr val="64748B"/>
+                </a:solidFill>
+              </a:defRPr>
+            </a:pPr>
+            <a:r>
+              <a:t>  建立單一全景數位儀表板，將分散於教育、衛政、工務、採購與社群的資訊一站式打通。</a:t>
             </a:r>
           </a:p>
           <a:p>
             <a:pPr>
               <a:spcBef>
-                <a:spcPts val="600"/>
+                <a:spcPts val="800"/>
               </a:spcBef>
-              <a:defRPr sz="1200" b="1">
-                <a:solidFill>
-                  <a:srgbClr val="0F172A"/>
-                </a:solidFill>
-              </a:defRPr>
-            </a:pPr>
-            <a:r>
-              <a:t>✓ 1. 裁罰法規違規維度 (35%)：</a:t>
+              <a:defRPr sz="1300" b="1">
+                <a:solidFill>
+                  <a:srgbClr val="2563EB"/>
+                </a:solidFill>
+              </a:defRPr>
+            </a:pPr>
+            <a:r>
+              <a:t>• 標準量化評分 (0~100分)：</a:t>
             </a:r>
           </a:p>
           <a:p>
@@ -4658,22 +4631,22 @@
               </a:defRPr>
             </a:pPr>
             <a:r>
-              <a:t>   累計違規處分字號、超收幼童人數、黑牌教保員記點</a:t>
+              <a:t>  不再依賴主觀經驗判斷，透過多因子動態權重模型自動給予量化分數與風險等級。</a:t>
             </a:r>
           </a:p>
           <a:p>
             <a:pPr>
               <a:spcBef>
-                <a:spcPts val="600"/>
+                <a:spcPts val="800"/>
               </a:spcBef>
-              <a:defRPr sz="1200" b="1">
-                <a:solidFill>
-                  <a:srgbClr val="0F172A"/>
-                </a:solidFill>
-              </a:defRPr>
-            </a:pPr>
-            <a:r>
-              <a:t>✓ 2. 班佛採購財務維度 (20%)：</a:t>
+              <a:defRPr sz="1300" b="1">
+                <a:solidFill>
+                  <a:srgbClr val="2563EB"/>
+                </a:solidFill>
+              </a:defRPr>
+            </a:pPr>
+            <a:r>
+              <a:t>• 大幅減輕稽查負擔：</a:t>
             </a:r>
           </a:p>
           <a:p>
@@ -4685,22 +4658,22 @@
               </a:defRPr>
             </a:pPr>
             <a:r>
-              <a:t>   大宗食材與校舍修繕合約，導入 Benford's Law 假帳防弊</a:t>
+              <a:t>  自動完成事前資料交叉勾稽與預警標註，讓教育局官員一秒掌握全市風險態勢。</a:t>
             </a:r>
           </a:p>
           <a:p>
             <a:pPr>
               <a:spcBef>
-                <a:spcPts val="600"/>
+                <a:spcPts val="800"/>
               </a:spcBef>
-              <a:defRPr sz="1200" b="1">
-                <a:solidFill>
-                  <a:srgbClr val="0F172A"/>
-                </a:solidFill>
-              </a:defRPr>
-            </a:pPr>
-            <a:r>
-              <a:t>✓ 3. 社群負面輿情維度 (20%)：</a:t>
+              <a:defRPr sz="1300" b="1">
+                <a:solidFill>
+                  <a:srgbClr val="2563EB"/>
+                </a:solidFill>
+              </a:defRPr>
+            </a:pPr>
+            <a:r>
+              <a:t>• 智慧決策與資源最佳化：</a:t>
             </a:r>
           </a:p>
           <a:p>
@@ -4712,61 +4685,7 @@
               </a:defRPr>
             </a:pPr>
             <a:r>
-              <a:t>   Google Places 公開評價與家長留言 NLP 情感分析</a:t>
-            </a:r>
-          </a:p>
-          <a:p>
-            <a:pPr>
-              <a:spcBef>
-                <a:spcPts val="600"/>
-              </a:spcBef>
-              <a:defRPr sz="1200" b="1">
-                <a:solidFill>
-                  <a:srgbClr val="0F172A"/>
-                </a:solidFill>
-              </a:defRPr>
-            </a:pPr>
-            <a:r>
-              <a:t>✓ 4. 師資異動流動維度 (15%)：</a:t>
-            </a:r>
-          </a:p>
-          <a:p>
-            <a:pPr>
-              <a:defRPr sz="1100">
-                <a:solidFill>
-                  <a:srgbClr val="64748B"/>
-                </a:solidFill>
-              </a:defRPr>
-            </a:pPr>
-            <a:r>
-              <a:t>   核心師資年度流動率異常、投保在職核備合規追蹤</a:t>
-            </a:r>
-          </a:p>
-          <a:p>
-            <a:pPr>
-              <a:spcBef>
-                <a:spcPts val="600"/>
-              </a:spcBef>
-              <a:defRPr sz="1200" b="1">
-                <a:solidFill>
-                  <a:srgbClr val="0F172A"/>
-                </a:solidFill>
-              </a:defRPr>
-            </a:pPr>
-            <a:r>
-              <a:t>✓ 5. 環境公安食安維度 (10%)：</a:t>
-            </a:r>
-          </a:p>
-          <a:p>
-            <a:pPr>
-              <a:defRPr sz="1100">
-                <a:solidFill>
-                  <a:srgbClr val="64748B"/>
-                </a:solidFill>
-              </a:defRPr>
-            </a:pPr>
-            <a:r>
-              <a:t>   校舍防墜設施檢驗合格證明、午餐廚房 48h 留樣履歷</a:t>
+              <a:t>  系統自動排定稽查優先順序，將專任稽查小組精準部署至真正有隱患的高風險機構。</a:t>
             </a:r>
           </a:p>
         </p:txBody>
@@ -4862,7 +4781,7 @@
               </a:defRPr>
             </a:pPr>
             <a:r>
-              <a:t>AWS 黑客松競賽提案 ｜ 項目一 ｜ 解決方案說明</a:t>
+              <a:t>AWS 黑客松競賽提案 ｜ 教育局命題：教保機構風險監測 ｜ 壹、解決方案說明 (分級成效)</a:t>
             </a:r>
           </a:p>
         </p:txBody>
@@ -4890,14 +4809,14 @@
           <a:lstStyle/>
           <a:p>
             <a:pPr>
-              <a:defRPr sz="2300" b="1">
+              <a:defRPr sz="2200" b="1">
                 <a:solidFill>
                   <a:srgbClr val="0F172A"/>
                 </a:solidFill>
               </a:defRPr>
             </a:pPr>
             <a:r>
-              <a:t>項目一、解決方案說明：新北市 468 所機構實測分級</a:t>
+              <a:t>解決方案說明：新北 468 所機構三級風險智慧分流</a:t>
             </a:r>
           </a:p>
         </p:txBody>
@@ -4992,7 +4911,7 @@
               </a:defRPr>
             </a:pPr>
             <a:r>
-              <a:t>28 所 (6%)  【處置：3 日內重點突擊稽查】</a:t>
+              <a:t>28 所 (6%)  【處置：3 日內突擊無預警稽查】</a:t>
             </a:r>
           </a:p>
           <a:p>
@@ -5012,12 +4931,12 @@
             <a:br/>
             <a:br/>
             <a:r>
-              <a:t>典型特徵：涉及重大違規超收（如超收 28 人重罰 18 萬）、不當管教查證屬實、班佛定律高度假帳警示。</a:t>
+              <a:t>典型特徵：涉及重大超收（如超收 28 人重罰 18 萬）、不當管教查證屬實、班佛定律高度假帳警示。</a:t>
             </a:r>
             <a:br/>
             <a:br/>
             <a:r>
-              <a:t>局端行動：由 Bedrock 產出實地稽查清單，排定公安食安小組 3 日內無預警現場盤查。</a:t>
+              <a:t>決策支援：系統直接由 Bedrock 產出實地稽查指引，排定公安食安聯合督導小組 3 日內實地突擊抽查。</a:t>
             </a:r>
           </a:p>
         </p:txBody>
@@ -5132,12 +5051,12 @@
             <a:br/>
             <a:br/>
             <a:r>
-              <a:t>典型特徵：偶發行政申報延宕、防墜設施微損限期改善、食材登錄漏填、評論出現負向關鍵字。</a:t>
+              <a:t>典型特徵：偶發行政申報延宕、防墜設施微損限期改善、食材登錄漏填、家長社群出現負向關鍵字。</a:t>
             </a:r>
             <a:br/>
             <a:br/>
             <a:r>
-              <a:t>局端行動：列入輔導名單，限期 30 天上傳改善照片，並排定次學期優先抽檢。</a:t>
+              <a:t>決策支援：列入輔導改善名冊，限期 30 天線上上傳佐證，並排定次學期優先實地抽驗。</a:t>
             </a:r>
           </a:p>
         </p:txBody>
@@ -5232,7 +5151,7 @@
               </a:defRPr>
             </a:pPr>
             <a:r>
-              <a:t>384 所 (82%)  【處置：常態例行自主備查】</a:t>
+              <a:t>384 所 (82%)  【處置：常態例行線上備查】</a:t>
             </a:r>
           </a:p>
           <a:p>
@@ -5252,12 +5171,12 @@
             <a:br/>
             <a:br/>
             <a:r>
-              <a:t>典型特徵：營運良好、各項食安公安登錄完整、防墜驗證齊備、家長網路社群正面評價高。</a:t>
+              <a:t>典型特徵：各項食安登錄完整、防墜驗證合格齊備、師資核備齊全、家長網路社群正面口碑佳。</a:t>
             </a:r>
             <a:br/>
             <a:br/>
             <a:r>
-              <a:t>局端行動：常態線上書面備查，大幅釋放稽查人力，將公務能量聚焦於高風險未爆彈。</a:t>
+              <a:t>決策支援：維持常態書面線上備查，大幅釋放 82% 常規普查人力，落實公務資源效益最大化。</a:t>
             </a:r>
           </a:p>
         </p:txBody>
@@ -5353,7 +5272,7 @@
               </a:defRPr>
             </a:pPr>
             <a:r>
-              <a:t>AWS 黑客松競賽提案 ｜ 項目二 ｜ 數據及資料運用</a:t>
+              <a:t>AWS 黑客松競賽提案 ｜ 教育局命題：教保機構風險監測 ｜ 貳、數據及資料運用</a:t>
             </a:r>
           </a:p>
         </p:txBody>
@@ -5381,14 +5300,14 @@
           <a:lstStyle/>
           <a:p>
             <a:pPr>
-              <a:defRPr sz="2300" b="1">
+              <a:defRPr sz="2200" b="1">
                 <a:solidFill>
                   <a:srgbClr val="0F172A"/>
                 </a:solidFill>
               </a:defRPr>
             </a:pPr>
             <a:r>
-              <a:t>項目二、數據及資料運用：4 大數據源與防弊演算法</a:t>
+              <a:t>數據及資料運用：4 大官方數據源與核心防弊模型</a:t>
             </a:r>
           </a:p>
         </p:txBody>
@@ -5446,7 +5365,7 @@
         </p:nvSpPr>
         <p:spPr>
           <a:xfrm>
-            <a:off x="960120" y="1874519"/>
+            <a:off x="960120" y="1828800"/>
             <a:ext cx="4754880" cy="3931920"/>
           </a:xfrm>
           <a:prstGeom prst="rect">
@@ -5468,7 +5387,7 @@
               </a:defRPr>
             </a:pPr>
             <a:r>
-              <a:t>📥 四大多源異質官方數據前處理</a:t>
+              <a:t>📥 四大多源異質官方數據匯流</a:t>
             </a:r>
           </a:p>
           <a:p>
@@ -5495,7 +5414,7 @@
               </a:defRPr>
             </a:pPr>
             <a:r>
-              <a:t>   串接幼托立案許可、核定收托名額、歷史違規處分字號與違反法條。</a:t>
+              <a:t>   串接全台幼托登記立案證號、核定收托人數、歷史裁罰處分字號與違反法條。</a:t>
             </a:r>
           </a:p>
           <a:p>
@@ -5522,7 +5441,7 @@
               </a:defRPr>
             </a:pPr>
             <a:r>
-              <a:t>   整合新北 29 區公私立高中職、國中、國小規模、學區與午餐合約。</a:t>
+              <a:t>   整合新北 29 區公私立高中職、國中、國小全學制規模、學區與營養午餐合約。</a:t>
             </a:r>
           </a:p>
           <a:p>
@@ -5549,7 +5468,7 @@
               </a:defRPr>
             </a:pPr>
             <a:r>
-              <a:t>   擷取食材供應、設備採購與校舍防墜工程之招標決標金額（供防弊分析）。</a:t>
+              <a:t>   擷取大宗食材、設施採購與防墜修繕工程之招決標金額數據（供假帳檢定）。</a:t>
             </a:r>
           </a:p>
           <a:p>
@@ -5576,7 +5495,7 @@
               </a:defRPr>
             </a:pPr>
             <a:r>
-              <a:t>   採集家長真實評分（1~5星）、評論則數與最新留言文本進行 NLP 探勘。</a:t>
+              <a:t>   即時採集家長真實評分星等（1~5星）、評論則數與最新留言文本進行 NLP 探勘。</a:t>
             </a:r>
           </a:p>
         </p:txBody>
@@ -5634,7 +5553,7 @@
         </p:nvSpPr>
         <p:spPr>
           <a:xfrm>
-            <a:off x="6446520" y="1874519"/>
+            <a:off x="6446520" y="1828800"/>
             <a:ext cx="4754880" cy="3931920"/>
           </a:xfrm>
           <a:prstGeom prst="rect">
@@ -5656,7 +5575,7 @@
               </a:defRPr>
             </a:pPr>
             <a:r>
-              <a:t>⚙️ 核心防弊演算法與量化模型</a:t>
+              <a:t>⚙️ 兩大防弊檢定與動態量化演算法</a:t>
             </a:r>
           </a:p>
           <a:p>
@@ -5683,7 +5602,7 @@
               </a:defRPr>
             </a:pPr>
             <a:r>
-              <a:t>分析採購標案金額首位數字機率分佈 P(d)=log10(1+1/d)。若卡方檢定 p-value &lt; 0.05 且首位反常集中於特定數字，自動觸發人為假帳與刻意拆單防弊告警。</a:t>
+              <a:t>分析採購金額首位數字機率分佈 P(d)=log10(1+1/d)。若卡方檢定 p-value &lt; 0.05 且首位反常集中於特定數字，自動觸發人為假帳與刻意拆單規避招標告警。</a:t>
             </a:r>
           </a:p>
           <a:p>
@@ -5698,7 +5617,7 @@
               </a:defRPr>
             </a:pPr>
             <a:r>
-              <a:t>🔍 多因子動態風險指數綜合評估模型</a:t>
+              <a:t>🔍 多因子動態風險指數評分引擎</a:t>
             </a:r>
           </a:p>
           <a:p>
@@ -5710,7 +5629,7 @@
               </a:defRPr>
             </a:pPr>
             <a:r>
-              <a:t>綜合治理指數 = 裁罰 (35%) + 班佛 (20%) + 輿情 (20%) + 師生比 (15%) + 公安 (10%)，動態量化為 0~100 風險分。</a:t>
+              <a:t>綜合治理指數 = 裁罰 (35%) + 班佛 (20%) + 輿情 (20%) + 師生比 (15%) + 公安 (10%)，動態量化為 0~100 分。</a:t>
             </a:r>
           </a:p>
           <a:p>
@@ -5725,7 +5644,7 @@
               </a:defRPr>
             </a:pPr>
             <a:r>
-              <a:t>🔍 NLP 負面情感與違規關鍵字探勘</a:t>
+              <a:t>🔍 NLP 負面情感與違規關鍵詞探勘</a:t>
             </a:r>
           </a:p>
           <a:p>
@@ -5737,7 +5656,7 @@
               </a:defRPr>
             </a:pPr>
             <a:r>
-              <a:t>自動比對「超收、體罰、推搡、未核備、拉肚子、髒亂」等負向關鍵詞，提早發掘隱性家長投訴不滿。</a:t>
+              <a:t>自動比對「超收、體罰、推搡、未核備、拉肚子、髒亂」等負向關鍵詞，提取潛在家長投訴意向，提早發掘隱性未爆彈。</a:t>
             </a:r>
           </a:p>
         </p:txBody>
@@ -5833,7 +5752,7 @@
               </a:defRPr>
             </a:pPr>
             <a:r>
-              <a:t>AWS 黑客松競賽提案 ｜ 項目三 ｜ AWS 雲端技術架構 (架構圖)</a:t>
+              <a:t>AWS 黑客松競賽提案 ｜ 教育局命題：教保機構風險監測 ｜ 參、AWS 雲端技術架構 (架構圖)</a:t>
             </a:r>
           </a:p>
         </p:txBody>
@@ -5861,14 +5780,14 @@
           <a:lstStyle/>
           <a:p>
             <a:pPr>
-              <a:defRPr sz="2300" b="1">
+              <a:defRPr sz="2200" b="1">
                 <a:solidFill>
                   <a:srgbClr val="0F172A"/>
                 </a:solidFill>
               </a:defRPr>
             </a:pPr>
             <a:r>
-              <a:t>項目三、AWS 雲端技術架構：全端拓撲架構圖</a:t>
+              <a:t>AWS 雲端技術架構：全端雲端拓撲架構圖</a:t>
             </a:r>
           </a:p>
         </p:txBody>
@@ -6379,7 +6298,7 @@
               </a:defRPr>
             </a:pPr>
             <a:r>
-              <a:t>AWS 黑客松競賽提案 ｜ 項目四 ｜ 解決方案使用介面</a:t>
+              <a:t>AWS 黑客松競賽提案 ｜ 教育局命題：教保機構風險監測 ｜ 肆、使用介面及操作流程</a:t>
             </a:r>
           </a:p>
         </p:txBody>
@@ -6407,14 +6326,14 @@
           <a:lstStyle/>
           <a:p>
             <a:pPr>
-              <a:defRPr sz="2300" b="1">
+              <a:defRPr sz="2200" b="1">
                 <a:solidFill>
                   <a:srgbClr val="0F172A"/>
                 </a:solidFill>
               </a:defRPr>
             </a:pPr>
             <a:r>
-              <a:t>項目四、使用介面及操作流程：GIS 熱點圖台與名冊</a:t>
+              <a:t>使用介面及操作流程：GIS 熱點圖台與機構名冊</a:t>
             </a:r>
           </a:p>
         </p:txBody>
@@ -6886,7 +6805,7 @@
               </a:defRPr>
             </a:pPr>
             <a:r>
-              <a:t>AWS 黑客松競賽提案 ｜ 項目四 ｜ 操作流程與創新功能</a:t>
+              <a:t>AWS 黑客松競賽提案 ｜ 教育局命題：教保機構風險監測 ｜ 肆、使用介面及操作流程</a:t>
             </a:r>
           </a:p>
         </p:txBody>
@@ -6914,14 +6833,14 @@
           <a:lstStyle/>
           <a:p>
             <a:pPr>
-              <a:defRPr sz="2300" b="1">
+              <a:defRPr sz="2200" b="1">
                 <a:solidFill>
                   <a:srgbClr val="0F172A"/>
                 </a:solidFill>
               </a:defRPr>
             </a:pPr>
             <a:r>
-              <a:t>項目四、使用介面及操作流程：稽查 SOP 與雙校雷達</a:t>
+              <a:t>使用介面及操作流程：稽查 SOP 與雙校雷達對比</a:t>
             </a:r>
           </a:p>
         </p:txBody>
@@ -7189,7 +7108,7 @@
               </a:defRPr>
             </a:pPr>
             <a:r>
-              <a:t>⚖️ 雙校五維雷達對比與匿名吹哨者</a:t>
+              <a:t>⚖️ 雙校五維雷達對比與創新亮點</a:t>
             </a:r>
           </a:p>
           <a:p>
@@ -7393,7 +7312,7 @@
               </a:defRPr>
             </a:pPr>
             <a:r>
-              <a:t>AWS 黑客松競賽提案 ｜ 預期效益與社會價值</a:t>
+              <a:t>AWS 黑客松競賽提案 ｜ 教育局命題：教保機構風險監測 ｜ 預期效益與社會價值</a:t>
             </a:r>
           </a:p>
         </p:txBody>
@@ -7421,7 +7340,7 @@
           <a:lstStyle/>
           <a:p>
             <a:pPr>
-              <a:defRPr sz="2300" b="1">
+              <a:defRPr sz="2200" b="1">
                 <a:solidFill>
                   <a:srgbClr val="0F172A"/>
                 </a:solidFill>

</xml_diff>